<commit_message>
Update coneptual fourier fig based on Topher's suggestion on slack
</commit_message>
<xml_diff>
--- a/Figures/concept_fig_editable.pptx
+++ b/Figures/concept_fig_editable.pptx
@@ -297,7 +297,7 @@
           <a:p>
             <a:fld id="{E6744CE3-0875-4B69-89C0-6F72D8139561}" type="datetimeFigureOut">
               <a:rPr lang="en-GB" smtClean="0"/>
-              <a:t>25/07/2024</a:t>
+              <a:t>26/07/2024</a:t>
             </a:fld>
             <a:endParaRPr lang="en-GB"/>
           </a:p>
@@ -467,7 +467,7 @@
           <a:p>
             <a:fld id="{E6744CE3-0875-4B69-89C0-6F72D8139561}" type="datetimeFigureOut">
               <a:rPr lang="en-GB" smtClean="0"/>
-              <a:t>25/07/2024</a:t>
+              <a:t>26/07/2024</a:t>
             </a:fld>
             <a:endParaRPr lang="en-GB"/>
           </a:p>
@@ -713,7 +713,7 @@
           <a:p>
             <a:fld id="{E6744CE3-0875-4B69-89C0-6F72D8139561}" type="datetimeFigureOut">
               <a:rPr lang="en-GB" smtClean="0"/>
-              <a:t>25/07/2024</a:t>
+              <a:t>26/07/2024</a:t>
             </a:fld>
             <a:endParaRPr lang="en-GB"/>
           </a:p>
@@ -1001,7 +1001,7 @@
           <a:p>
             <a:fld id="{E6744CE3-0875-4B69-89C0-6F72D8139561}" type="datetimeFigureOut">
               <a:rPr lang="en-GB" smtClean="0"/>
-              <a:t>25/07/2024</a:t>
+              <a:t>26/07/2024</a:t>
             </a:fld>
             <a:endParaRPr lang="en-GB"/>
           </a:p>
@@ -1423,7 +1423,7 @@
           <a:p>
             <a:fld id="{E6744CE3-0875-4B69-89C0-6F72D8139561}" type="datetimeFigureOut">
               <a:rPr lang="en-GB" smtClean="0"/>
-              <a:t>25/07/2024</a:t>
+              <a:t>26/07/2024</a:t>
             </a:fld>
             <a:endParaRPr lang="en-GB"/>
           </a:p>
@@ -1541,7 +1541,7 @@
           <a:p>
             <a:fld id="{E6744CE3-0875-4B69-89C0-6F72D8139561}" type="datetimeFigureOut">
               <a:rPr lang="en-GB" smtClean="0"/>
-              <a:t>25/07/2024</a:t>
+              <a:t>26/07/2024</a:t>
             </a:fld>
             <a:endParaRPr lang="en-GB"/>
           </a:p>
@@ -1636,7 +1636,7 @@
           <a:p>
             <a:fld id="{E6744CE3-0875-4B69-89C0-6F72D8139561}" type="datetimeFigureOut">
               <a:rPr lang="en-GB" smtClean="0"/>
-              <a:t>25/07/2024</a:t>
+              <a:t>26/07/2024</a:t>
             </a:fld>
             <a:endParaRPr lang="en-GB"/>
           </a:p>
@@ -1849,7 +1849,7 @@
           <a:p>
             <a:fld id="{E6744CE3-0875-4B69-89C0-6F72D8139561}" type="datetimeFigureOut">
               <a:rPr lang="en-GB" smtClean="0"/>
-              <a:t>25/07/2024</a:t>
+              <a:t>26/07/2024</a:t>
             </a:fld>
             <a:endParaRPr lang="en-GB"/>
           </a:p>
@@ -2882,10 +2882,10 @@
       </p:grpSpPr>
       <p:grpSp>
         <p:nvGrpSpPr>
-          <p:cNvPr id="102" name="Group 101">
+          <p:cNvPr id="8" name="Group 7">
             <a:extLst>
               <a:ext uri="{FF2B5EF4-FFF2-40B4-BE49-F238E27FC236}">
-                <a16:creationId xmlns:a16="http://schemas.microsoft.com/office/drawing/2014/main" id="{F6FFEA19-96BE-4BE7-2447-D780FEE19892}"/>
+                <a16:creationId xmlns:a16="http://schemas.microsoft.com/office/drawing/2014/main" id="{33EB0A24-0980-C22E-4F90-123436975B96}"/>
               </a:ext>
             </a:extLst>
           </p:cNvPr>
@@ -2895,9 +2895,9 @@
         <p:grpSpPr>
           <a:xfrm>
             <a:off x="505983" y="260648"/>
-            <a:ext cx="8242481" cy="6201980"/>
+            <a:ext cx="8242481" cy="6336704"/>
             <a:chOff x="505983" y="260648"/>
-            <a:chExt cx="8242481" cy="6201980"/>
+            <a:chExt cx="8242481" cy="6336704"/>
           </a:xfrm>
         </p:grpSpPr>
         <p:sp>
@@ -2914,8 +2914,8 @@
           </p:nvSpPr>
           <p:spPr>
             <a:xfrm>
-              <a:off x="505983" y="260648"/>
-              <a:ext cx="8242481" cy="6201980"/>
+              <a:off x="544123" y="260648"/>
+              <a:ext cx="8204341" cy="6336704"/>
             </a:xfrm>
             <a:prstGeom prst="rect">
               <a:avLst/>
@@ -2954,12 +2954,223 @@
             </a:p>
           </p:txBody>
         </p:sp>
+        <p:pic>
+          <p:nvPicPr>
+            <p:cNvPr id="30" name="Picture 29" descr="A graph showing time and time&#10;&#10;Description automatically generated">
+              <a:extLst>
+                <a:ext uri="{FF2B5EF4-FFF2-40B4-BE49-F238E27FC236}">
+                  <a16:creationId xmlns:a16="http://schemas.microsoft.com/office/drawing/2014/main" id="{E489C5DC-26F3-ECF6-EE84-29DE4BAC3766}"/>
+                </a:ext>
+              </a:extLst>
+            </p:cNvPr>
+            <p:cNvPicPr>
+              <a:picLocks noChangeAspect="1"/>
+            </p:cNvPicPr>
+            <p:nvPr/>
+          </p:nvPicPr>
+          <p:blipFill>
+            <a:blip r:embed="rId2">
+              <a:extLst>
+                <a:ext uri="{28A0092B-C50C-407E-A947-70E740481C1C}">
+                  <a14:useLocalDpi xmlns:a14="http://schemas.microsoft.com/office/drawing/2010/main" val="0"/>
+                </a:ext>
+              </a:extLst>
+            </a:blip>
+            <a:stretch>
+              <a:fillRect/>
+            </a:stretch>
+          </p:blipFill>
+          <p:spPr>
+            <a:xfrm>
+              <a:off x="635413" y="701988"/>
+              <a:ext cx="2743200" cy="1371600"/>
+            </a:xfrm>
+            <a:prstGeom prst="rect">
+              <a:avLst/>
+            </a:prstGeom>
+          </p:spPr>
+        </p:pic>
+        <p:pic>
+          <p:nvPicPr>
+            <p:cNvPr id="34" name="Picture 33" descr="A set of colorful lines&#10;&#10;Description automatically generated with medium confidence">
+              <a:extLst>
+                <a:ext uri="{FF2B5EF4-FFF2-40B4-BE49-F238E27FC236}">
+                  <a16:creationId xmlns:a16="http://schemas.microsoft.com/office/drawing/2014/main" id="{E3DC1B72-B027-064F-402F-EE663B6FD6BC}"/>
+                </a:ext>
+              </a:extLst>
+            </p:cNvPr>
+            <p:cNvPicPr>
+              <a:picLocks/>
+            </p:cNvPicPr>
+            <p:nvPr/>
+          </p:nvPicPr>
+          <p:blipFill rotWithShape="1">
+            <a:blip r:embed="rId3">
+              <a:extLst>
+                <a:ext uri="{28A0092B-C50C-407E-A947-70E740481C1C}">
+                  <a14:useLocalDpi xmlns:a14="http://schemas.microsoft.com/office/drawing/2010/main" val="0"/>
+                </a:ext>
+              </a:extLst>
+            </a:blip>
+            <a:srcRect b="35117"/>
+            <a:stretch/>
+          </p:blipFill>
+          <p:spPr>
+            <a:xfrm>
+              <a:off x="505983" y="2073588"/>
+              <a:ext cx="3002059" cy="2660848"/>
+            </a:xfrm>
+            <a:prstGeom prst="rect">
+              <a:avLst/>
+            </a:prstGeom>
+          </p:spPr>
+        </p:pic>
+        <p:pic>
+          <p:nvPicPr>
+            <p:cNvPr id="35" name="Picture 34" descr="A set of colorful lines&#10;&#10;Description automatically generated with medium confidence">
+              <a:extLst>
+                <a:ext uri="{FF2B5EF4-FFF2-40B4-BE49-F238E27FC236}">
+                  <a16:creationId xmlns:a16="http://schemas.microsoft.com/office/drawing/2014/main" id="{D49E2E77-2B59-0A8B-1BAB-CFB900EAE525}"/>
+                </a:ext>
+              </a:extLst>
+            </p:cNvPr>
+            <p:cNvPicPr>
+              <a:picLocks/>
+            </p:cNvPicPr>
+            <p:nvPr/>
+          </p:nvPicPr>
+          <p:blipFill rotWithShape="1">
+            <a:blip r:embed="rId3">
+              <a:extLst>
+                <a:ext uri="{28A0092B-C50C-407E-A947-70E740481C1C}">
+                  <a14:useLocalDpi xmlns:a14="http://schemas.microsoft.com/office/drawing/2010/main" val="0"/>
+                </a:ext>
+              </a:extLst>
+            </a:blip>
+            <a:srcRect t="64883" b="19314"/>
+            <a:stretch/>
+          </p:blipFill>
+          <p:spPr>
+            <a:xfrm>
+              <a:off x="505983" y="4878452"/>
+              <a:ext cx="3002059" cy="648072"/>
+            </a:xfrm>
+            <a:prstGeom prst="rect">
+              <a:avLst/>
+            </a:prstGeom>
+          </p:spPr>
+        </p:pic>
+        <p:sp>
+          <p:nvSpPr>
+            <p:cNvPr id="36" name="TextBox 35">
+              <a:extLst>
+                <a:ext uri="{FF2B5EF4-FFF2-40B4-BE49-F238E27FC236}">
+                  <a16:creationId xmlns:a16="http://schemas.microsoft.com/office/drawing/2014/main" id="{4B255398-1857-15EA-EF97-E90262C2300D}"/>
+                </a:ext>
+              </a:extLst>
+            </p:cNvPr>
+            <p:cNvSpPr txBox="1"/>
+            <p:nvPr/>
+          </p:nvSpPr>
+          <p:spPr>
+            <a:xfrm rot="5400000">
+              <a:off x="1966690" y="4606389"/>
+              <a:ext cx="432048" cy="400110"/>
+            </a:xfrm>
+            <a:prstGeom prst="rect">
+              <a:avLst/>
+            </a:prstGeom>
+            <a:noFill/>
+          </p:spPr>
+          <p:txBody>
+            <a:bodyPr wrap="square" rtlCol="0">
+              <a:spAutoFit/>
+            </a:bodyPr>
+            <a:lstStyle/>
+            <a:p>
+              <a:r>
+                <a:rPr lang="en-US" sz="2000" dirty="0"/>
+                <a:t>… </a:t>
+              </a:r>
+            </a:p>
+          </p:txBody>
+        </p:sp>
+        <p:pic>
+          <p:nvPicPr>
+            <p:cNvPr id="37" name="Picture 36" descr="A set of colorful lines&#10;&#10;Description automatically generated with medium confidence">
+              <a:extLst>
+                <a:ext uri="{FF2B5EF4-FFF2-40B4-BE49-F238E27FC236}">
+                  <a16:creationId xmlns:a16="http://schemas.microsoft.com/office/drawing/2014/main" id="{B823085F-C1B7-5F90-D1A2-108ECD188B50}"/>
+                </a:ext>
+              </a:extLst>
+            </p:cNvPr>
+            <p:cNvPicPr>
+              <a:picLocks/>
+            </p:cNvPicPr>
+            <p:nvPr/>
+          </p:nvPicPr>
+          <p:blipFill rotWithShape="1">
+            <a:blip r:embed="rId3">
+              <a:extLst>
+                <a:ext uri="{28A0092B-C50C-407E-A947-70E740481C1C}">
+                  <a14:useLocalDpi xmlns:a14="http://schemas.microsoft.com/office/drawing/2010/main" val="0"/>
+                </a:ext>
+              </a:extLst>
+            </a:blip>
+            <a:srcRect t="80685"/>
+            <a:stretch/>
+          </p:blipFill>
+          <p:spPr>
+            <a:xfrm>
+              <a:off x="505983" y="5670540"/>
+              <a:ext cx="3002059" cy="792088"/>
+            </a:xfrm>
+            <a:prstGeom prst="rect">
+              <a:avLst/>
+            </a:prstGeom>
+          </p:spPr>
+        </p:pic>
+        <p:sp>
+          <p:nvSpPr>
+            <p:cNvPr id="38" name="TextBox 37">
+              <a:extLst>
+                <a:ext uri="{FF2B5EF4-FFF2-40B4-BE49-F238E27FC236}">
+                  <a16:creationId xmlns:a16="http://schemas.microsoft.com/office/drawing/2014/main" id="{B9CBE40E-AB89-C553-D409-0EB985027AAC}"/>
+                </a:ext>
+              </a:extLst>
+            </p:cNvPr>
+            <p:cNvSpPr txBox="1"/>
+            <p:nvPr/>
+          </p:nvSpPr>
+          <p:spPr>
+            <a:xfrm rot="5400000">
+              <a:off x="1966690" y="5398477"/>
+              <a:ext cx="432048" cy="400110"/>
+            </a:xfrm>
+            <a:prstGeom prst="rect">
+              <a:avLst/>
+            </a:prstGeom>
+            <a:noFill/>
+          </p:spPr>
+          <p:txBody>
+            <a:bodyPr wrap="square" rtlCol="0">
+              <a:spAutoFit/>
+            </a:bodyPr>
+            <a:lstStyle/>
+            <a:p>
+              <a:r>
+                <a:rPr lang="en-US" sz="2000" dirty="0"/>
+                <a:t>… </a:t>
+              </a:r>
+            </a:p>
+          </p:txBody>
+        </p:sp>
         <p:grpSp>
           <p:nvGrpSpPr>
-            <p:cNvPr id="100" name="Group 99">
+            <p:cNvPr id="4" name="Group 3">
               <a:extLst>
                 <a:ext uri="{FF2B5EF4-FFF2-40B4-BE49-F238E27FC236}">
-                  <a16:creationId xmlns:a16="http://schemas.microsoft.com/office/drawing/2014/main" id="{FC96FC5E-43AB-1D52-44EA-1AD1E6E2845D}"/>
+                  <a16:creationId xmlns:a16="http://schemas.microsoft.com/office/drawing/2014/main" id="{B3A20E04-6E01-7B6D-E250-7815802ACCF8}"/>
                 </a:ext>
               </a:extLst>
             </p:cNvPr>
@@ -2968,18 +3179,18 @@
           </p:nvGrpSpPr>
           <p:grpSpPr>
             <a:xfrm>
-              <a:off x="505983" y="260648"/>
-              <a:ext cx="8132033" cy="6201980"/>
-              <a:chOff x="122090" y="35332"/>
-              <a:chExt cx="8132033" cy="6201980"/>
+              <a:off x="3538395" y="751065"/>
+              <a:ext cx="5091830" cy="1371600"/>
+              <a:chOff x="3544253" y="2875920"/>
+              <a:chExt cx="5091830" cy="1371600"/>
             </a:xfrm>
           </p:grpSpPr>
           <p:pic>
             <p:nvPicPr>
-              <p:cNvPr id="30" name="Picture 29" descr="A graph showing time and time&#10;&#10;Description automatically generated">
+              <p:cNvPr id="61" name="Picture 60" descr="A graph showing a line and time&#10;&#10;Description automatically generated with medium confidence">
                 <a:extLst>
                   <a:ext uri="{FF2B5EF4-FFF2-40B4-BE49-F238E27FC236}">
-                    <a16:creationId xmlns:a16="http://schemas.microsoft.com/office/drawing/2014/main" id="{E489C5DC-26F3-ECF6-EE84-29DE4BAC3766}"/>
+                    <a16:creationId xmlns:a16="http://schemas.microsoft.com/office/drawing/2014/main" id="{866762CA-586C-B34C-AB73-9E48EC542420}"/>
                   </a:ext>
                 </a:extLst>
               </p:cNvPr>
@@ -2989,7 +3200,7 @@
               <p:nvPr/>
             </p:nvPicPr>
             <p:blipFill>
-              <a:blip r:embed="rId2">
+              <a:blip r:embed="rId4">
                 <a:extLst>
                   <a:ext uri="{28A0092B-C50C-407E-A947-70E740481C1C}">
                     <a14:useLocalDpi xmlns:a14="http://schemas.microsoft.com/office/drawing/2010/main" val="0"/>
@@ -3002,7 +3213,7 @@
             </p:blipFill>
             <p:spPr>
               <a:xfrm>
-                <a:off x="251520" y="476672"/>
+                <a:off x="5892883" y="2875920"/>
                 <a:ext cx="2743200" cy="1371600"/>
               </a:xfrm>
               <a:prstGeom prst="rect">
@@ -3010,187 +3221,12 @@
               </a:prstGeom>
             </p:spPr>
           </p:pic>
-          <p:pic>
-            <p:nvPicPr>
-              <p:cNvPr id="34" name="Picture 33" descr="A set of colorful lines&#10;&#10;Description automatically generated with medium confidence">
+          <p:grpSp>
+            <p:nvGrpSpPr>
+              <p:cNvPr id="55" name="Group 54">
                 <a:extLst>
                   <a:ext uri="{FF2B5EF4-FFF2-40B4-BE49-F238E27FC236}">
-                    <a16:creationId xmlns:a16="http://schemas.microsoft.com/office/drawing/2014/main" id="{E3DC1B72-B027-064F-402F-EE663B6FD6BC}"/>
-                  </a:ext>
-                </a:extLst>
-              </p:cNvPr>
-              <p:cNvPicPr>
-                <a:picLocks/>
-              </p:cNvPicPr>
-              <p:nvPr/>
-            </p:nvPicPr>
-            <p:blipFill rotWithShape="1">
-              <a:blip r:embed="rId3">
-                <a:extLst>
-                  <a:ext uri="{28A0092B-C50C-407E-A947-70E740481C1C}">
-                    <a14:useLocalDpi xmlns:a14="http://schemas.microsoft.com/office/drawing/2010/main" val="0"/>
-                  </a:ext>
-                </a:extLst>
-              </a:blip>
-              <a:srcRect b="35117"/>
-              <a:stretch/>
-            </p:blipFill>
-            <p:spPr>
-              <a:xfrm>
-                <a:off x="122090" y="1848272"/>
-                <a:ext cx="3002059" cy="2660848"/>
-              </a:xfrm>
-              <a:prstGeom prst="rect">
-                <a:avLst/>
-              </a:prstGeom>
-            </p:spPr>
-          </p:pic>
-          <p:pic>
-            <p:nvPicPr>
-              <p:cNvPr id="35" name="Picture 34" descr="A set of colorful lines&#10;&#10;Description automatically generated with medium confidence">
-                <a:extLst>
-                  <a:ext uri="{FF2B5EF4-FFF2-40B4-BE49-F238E27FC236}">
-                    <a16:creationId xmlns:a16="http://schemas.microsoft.com/office/drawing/2014/main" id="{D49E2E77-2B59-0A8B-1BAB-CFB900EAE525}"/>
-                  </a:ext>
-                </a:extLst>
-              </p:cNvPr>
-              <p:cNvPicPr>
-                <a:picLocks/>
-              </p:cNvPicPr>
-              <p:nvPr/>
-            </p:nvPicPr>
-            <p:blipFill rotWithShape="1">
-              <a:blip r:embed="rId3">
-                <a:extLst>
-                  <a:ext uri="{28A0092B-C50C-407E-A947-70E740481C1C}">
-                    <a14:useLocalDpi xmlns:a14="http://schemas.microsoft.com/office/drawing/2010/main" val="0"/>
-                  </a:ext>
-                </a:extLst>
-              </a:blip>
-              <a:srcRect t="64883" b="19314"/>
-              <a:stretch/>
-            </p:blipFill>
-            <p:spPr>
-              <a:xfrm>
-                <a:off x="122090" y="4653136"/>
-                <a:ext cx="3002059" cy="648072"/>
-              </a:xfrm>
-              <a:prstGeom prst="rect">
-                <a:avLst/>
-              </a:prstGeom>
-            </p:spPr>
-          </p:pic>
-          <p:sp>
-            <p:nvSpPr>
-              <p:cNvPr id="36" name="TextBox 35">
-                <a:extLst>
-                  <a:ext uri="{FF2B5EF4-FFF2-40B4-BE49-F238E27FC236}">
-                    <a16:creationId xmlns:a16="http://schemas.microsoft.com/office/drawing/2014/main" id="{4B255398-1857-15EA-EF97-E90262C2300D}"/>
-                  </a:ext>
-                </a:extLst>
-              </p:cNvPr>
-              <p:cNvSpPr txBox="1"/>
-              <p:nvPr/>
-            </p:nvSpPr>
-            <p:spPr>
-              <a:xfrm rot="5400000">
-                <a:off x="1582797" y="4381073"/>
-                <a:ext cx="432048" cy="400110"/>
-              </a:xfrm>
-              <a:prstGeom prst="rect">
-                <a:avLst/>
-              </a:prstGeom>
-              <a:noFill/>
-            </p:spPr>
-            <p:txBody>
-              <a:bodyPr wrap="square" rtlCol="0">
-                <a:spAutoFit/>
-              </a:bodyPr>
-              <a:lstStyle/>
-              <a:p>
-                <a:r>
-                  <a:rPr lang="en-US" sz="2000" dirty="0"/>
-                  <a:t>… </a:t>
-                </a:r>
-              </a:p>
-            </p:txBody>
-          </p:sp>
-          <p:pic>
-            <p:nvPicPr>
-              <p:cNvPr id="37" name="Picture 36" descr="A set of colorful lines&#10;&#10;Description automatically generated with medium confidence">
-                <a:extLst>
-                  <a:ext uri="{FF2B5EF4-FFF2-40B4-BE49-F238E27FC236}">
-                    <a16:creationId xmlns:a16="http://schemas.microsoft.com/office/drawing/2014/main" id="{B823085F-C1B7-5F90-D1A2-108ECD188B50}"/>
-                  </a:ext>
-                </a:extLst>
-              </p:cNvPr>
-              <p:cNvPicPr>
-                <a:picLocks/>
-              </p:cNvPicPr>
-              <p:nvPr/>
-            </p:nvPicPr>
-            <p:blipFill rotWithShape="1">
-              <a:blip r:embed="rId3">
-                <a:extLst>
-                  <a:ext uri="{28A0092B-C50C-407E-A947-70E740481C1C}">
-                    <a14:useLocalDpi xmlns:a14="http://schemas.microsoft.com/office/drawing/2010/main" val="0"/>
-                  </a:ext>
-                </a:extLst>
-              </a:blip>
-              <a:srcRect t="80685"/>
-              <a:stretch/>
-            </p:blipFill>
-            <p:spPr>
-              <a:xfrm>
-                <a:off x="122090" y="5445224"/>
-                <a:ext cx="3002059" cy="792088"/>
-              </a:xfrm>
-              <a:prstGeom prst="rect">
-                <a:avLst/>
-              </a:prstGeom>
-            </p:spPr>
-          </p:pic>
-          <p:sp>
-            <p:nvSpPr>
-              <p:cNvPr id="38" name="TextBox 37">
-                <a:extLst>
-                  <a:ext uri="{FF2B5EF4-FFF2-40B4-BE49-F238E27FC236}">
-                    <a16:creationId xmlns:a16="http://schemas.microsoft.com/office/drawing/2014/main" id="{B9CBE40E-AB89-C553-D409-0EB985027AAC}"/>
-                  </a:ext>
-                </a:extLst>
-              </p:cNvPr>
-              <p:cNvSpPr txBox="1"/>
-              <p:nvPr/>
-            </p:nvSpPr>
-            <p:spPr>
-              <a:xfrm rot="5400000">
-                <a:off x="1582797" y="5173161"/>
-                <a:ext cx="432048" cy="400110"/>
-              </a:xfrm>
-              <a:prstGeom prst="rect">
-                <a:avLst/>
-              </a:prstGeom>
-              <a:noFill/>
-            </p:spPr>
-            <p:txBody>
-              <a:bodyPr wrap="square" rtlCol="0">
-                <a:spAutoFit/>
-              </a:bodyPr>
-              <a:lstStyle/>
-              <a:p>
-                <a:r>
-                  <a:rPr lang="en-US" sz="2000" dirty="0"/>
-                  <a:t>… </a:t>
-                </a:r>
-              </a:p>
-            </p:txBody>
-          </p:sp>
-          <p:grpSp>
-            <p:nvGrpSpPr>
-              <p:cNvPr id="95" name="Group 94">
-                <a:extLst>
-                  <a:ext uri="{FF2B5EF4-FFF2-40B4-BE49-F238E27FC236}">
-                    <a16:creationId xmlns:a16="http://schemas.microsoft.com/office/drawing/2014/main" id="{0C4309EC-8550-BAAB-4EFC-703AF6FF0965}"/>
+                    <a16:creationId xmlns:a16="http://schemas.microsoft.com/office/drawing/2014/main" id="{99DAD50E-7A2B-7192-B6B4-C42B40D55331}"/>
                   </a:ext>
                 </a:extLst>
               </p:cNvPr>
@@ -3199,18 +3235,18 @@
             </p:nvGrpSpPr>
             <p:grpSpPr>
               <a:xfrm>
-                <a:off x="5503950" y="980728"/>
-                <a:ext cx="2750173" cy="4711352"/>
-                <a:chOff x="6293296" y="877888"/>
-                <a:chExt cx="2750173" cy="4711352"/>
+                <a:off x="3544253" y="3067474"/>
+                <a:ext cx="2128513" cy="736774"/>
+                <a:chOff x="3064000" y="2379140"/>
+                <a:chExt cx="3007616" cy="736774"/>
               </a:xfrm>
             </p:grpSpPr>
             <p:pic>
               <p:nvPicPr>
-                <p:cNvPr id="59" name="Picture 58" descr="A graph showing a line&#10;&#10;Description automatically generated with medium confidence">
+                <p:cNvPr id="53" name="Picture 52" descr="A set of colorful lines&#10;&#10;Description automatically generated with medium confidence">
                   <a:extLst>
                     <a:ext uri="{FF2B5EF4-FFF2-40B4-BE49-F238E27FC236}">
-                      <a16:creationId xmlns:a16="http://schemas.microsoft.com/office/drawing/2014/main" id="{4F18A0D3-4D6F-7AF3-BAEA-0FF0E2C4E3A0}"/>
+                      <a16:creationId xmlns:a16="http://schemas.microsoft.com/office/drawing/2014/main" id="{4FC52D71-2FE1-0D61-3BC0-8B623942261F}"/>
                     </a:ext>
                   </a:extLst>
                 </p:cNvPr>
@@ -3219,22 +3255,21 @@
                 </p:cNvPicPr>
                 <p:nvPr/>
               </p:nvPicPr>
-              <p:blipFill>
-                <a:blip r:embed="rId4">
+              <p:blipFill rotWithShape="1">
+                <a:blip r:embed="rId3">
                   <a:extLst>
                     <a:ext uri="{28A0092B-C50C-407E-A947-70E740481C1C}">
                       <a14:useLocalDpi xmlns:a14="http://schemas.microsoft.com/office/drawing/2010/main" val="0"/>
                     </a:ext>
                   </a:extLst>
                 </a:blip>
-                <a:stretch>
-                  <a:fillRect/>
-                </a:stretch>
+                <a:srcRect t="6859" b="84446"/>
+                <a:stretch/>
               </p:blipFill>
               <p:spPr>
                 <a:xfrm>
-                  <a:off x="6293296" y="877888"/>
-                  <a:ext cx="2743200" cy="1371600"/>
+                  <a:off x="3072384" y="2379140"/>
+                  <a:ext cx="2999232" cy="356592"/>
                 </a:xfrm>
                 <a:prstGeom prst="rect">
                   <a:avLst/>
@@ -3243,10 +3278,10 @@
             </p:pic>
             <p:pic>
               <p:nvPicPr>
-                <p:cNvPr id="61" name="Picture 60" descr="A graph showing a line and time&#10;&#10;Description automatically generated with medium confidence">
+                <p:cNvPr id="54" name="Picture 53" descr="A set of colorful lines&#10;&#10;Description automatically generated with medium confidence">
                   <a:extLst>
                     <a:ext uri="{FF2B5EF4-FFF2-40B4-BE49-F238E27FC236}">
-                      <a16:creationId xmlns:a16="http://schemas.microsoft.com/office/drawing/2014/main" id="{866762CA-586C-B34C-AB73-9E48EC542420}"/>
+                      <a16:creationId xmlns:a16="http://schemas.microsoft.com/office/drawing/2014/main" id="{908DEEE1-9B1C-EFCC-4B5F-FC7900478E6E}"/>
                     </a:ext>
                   </a:extLst>
                 </p:cNvPr>
@@ -3255,58 +3290,21 @@
                 </p:cNvPicPr>
                 <p:nvPr/>
               </p:nvPicPr>
-              <p:blipFill>
-                <a:blip r:embed="rId5">
+              <p:blipFill rotWithShape="1">
+                <a:blip r:embed="rId3">
                   <a:extLst>
                     <a:ext uri="{28A0092B-C50C-407E-A947-70E740481C1C}">
                       <a14:useLocalDpi xmlns:a14="http://schemas.microsoft.com/office/drawing/2010/main" val="0"/>
                     </a:ext>
                   </a:extLst>
                 </a:blip>
-                <a:stretch>
-                  <a:fillRect/>
-                </a:stretch>
+                <a:srcRect t="15356" b="75949"/>
+                <a:stretch/>
               </p:blipFill>
               <p:spPr>
                 <a:xfrm>
-                  <a:off x="6298336" y="2547764"/>
-                  <a:ext cx="2743200" cy="1371600"/>
-                </a:xfrm>
-                <a:prstGeom prst="rect">
-                  <a:avLst/>
-                </a:prstGeom>
-              </p:spPr>
-            </p:pic>
-            <p:pic>
-              <p:nvPicPr>
-                <p:cNvPr id="63" name="Picture 62" descr="A graph showing a line of time&#10;&#10;Description automatically generated">
-                  <a:extLst>
-                    <a:ext uri="{FF2B5EF4-FFF2-40B4-BE49-F238E27FC236}">
-                      <a16:creationId xmlns:a16="http://schemas.microsoft.com/office/drawing/2014/main" id="{4670FD12-50CE-503B-BAA7-F976D5EA3117}"/>
-                    </a:ext>
-                  </a:extLst>
-                </p:cNvPr>
-                <p:cNvPicPr>
-                  <a:picLocks noChangeAspect="1"/>
-                </p:cNvPicPr>
-                <p:nvPr/>
-              </p:nvPicPr>
-              <p:blipFill>
-                <a:blip r:embed="rId6">
-                  <a:extLst>
-                    <a:ext uri="{28A0092B-C50C-407E-A947-70E740481C1C}">
-                      <a14:useLocalDpi xmlns:a14="http://schemas.microsoft.com/office/drawing/2010/main" val="0"/>
-                    </a:ext>
-                  </a:extLst>
-                </a:blip>
-                <a:stretch>
-                  <a:fillRect/>
-                </a:stretch>
-              </p:blipFill>
-              <p:spPr>
-                <a:xfrm>
-                  <a:off x="6300269" y="4217640"/>
-                  <a:ext cx="2743200" cy="1371600"/>
+                  <a:off x="3064000" y="2759322"/>
+                  <a:ext cx="2999232" cy="356592"/>
                 </a:xfrm>
                 <a:prstGeom prst="rect">
                   <a:avLst/>
@@ -3314,12 +3312,177 @@
               </p:spPr>
             </p:pic>
           </p:grpSp>
+          <p:sp>
+            <p:nvSpPr>
+              <p:cNvPr id="87" name="Right Arrow 86">
+                <a:extLst>
+                  <a:ext uri="{FF2B5EF4-FFF2-40B4-BE49-F238E27FC236}">
+                    <a16:creationId xmlns:a16="http://schemas.microsoft.com/office/drawing/2014/main" id="{FCA32D21-A010-E8A2-1053-513A97B98695}"/>
+                  </a:ext>
+                </a:extLst>
+              </p:cNvPr>
+              <p:cNvSpPr/>
+              <p:nvPr/>
+            </p:nvSpPr>
+            <p:spPr>
+              <a:xfrm>
+                <a:off x="5653591" y="3158902"/>
+                <a:ext cx="232268" cy="173736"/>
+              </a:xfrm>
+              <a:prstGeom prst="rightArrow">
+                <a:avLst/>
+              </a:prstGeom>
+              <a:solidFill>
+                <a:srgbClr val="00496F"/>
+              </a:solidFill>
+              <a:ln w="3175">
+                <a:solidFill>
+                  <a:schemeClr val="tx1"/>
+                </a:solidFill>
+              </a:ln>
+            </p:spPr>
+            <p:style>
+              <a:lnRef idx="2">
+                <a:schemeClr val="accent1">
+                  <a:shade val="15000"/>
+                </a:schemeClr>
+              </a:lnRef>
+              <a:fillRef idx="1">
+                <a:schemeClr val="accent1"/>
+              </a:fillRef>
+              <a:effectRef idx="0">
+                <a:schemeClr val="accent1"/>
+              </a:effectRef>
+              <a:fontRef idx="minor">
+                <a:schemeClr val="lt1"/>
+              </a:fontRef>
+            </p:style>
+            <p:txBody>
+              <a:bodyPr rtlCol="0" anchor="ctr"/>
+              <a:lstStyle/>
+              <a:p>
+                <a:pPr algn="ctr"/>
+                <a:endParaRPr lang="en-US"/>
+              </a:p>
+            </p:txBody>
+          </p:sp>
+          <p:sp>
+            <p:nvSpPr>
+              <p:cNvPr id="88" name="Right Arrow 87">
+                <a:extLst>
+                  <a:ext uri="{FF2B5EF4-FFF2-40B4-BE49-F238E27FC236}">
+                    <a16:creationId xmlns:a16="http://schemas.microsoft.com/office/drawing/2014/main" id="{8824C285-2611-8FF9-70B2-10C200B339F9}"/>
+                  </a:ext>
+                </a:extLst>
+              </p:cNvPr>
+              <p:cNvSpPr/>
+              <p:nvPr/>
+            </p:nvSpPr>
+            <p:spPr>
+              <a:xfrm>
+                <a:off x="5647030" y="3603821"/>
+                <a:ext cx="232268" cy="73152"/>
+              </a:xfrm>
+              <a:prstGeom prst="rightArrow">
+                <a:avLst/>
+              </a:prstGeom>
+              <a:solidFill>
+                <a:srgbClr val="0C7996"/>
+              </a:solidFill>
+              <a:ln w="3175">
+                <a:solidFill>
+                  <a:schemeClr val="tx1"/>
+                </a:solidFill>
+              </a:ln>
+            </p:spPr>
+            <p:style>
+              <a:lnRef idx="2">
+                <a:schemeClr val="accent1">
+                  <a:shade val="15000"/>
+                </a:schemeClr>
+              </a:lnRef>
+              <a:fillRef idx="1">
+                <a:schemeClr val="accent1"/>
+              </a:fillRef>
+              <a:effectRef idx="0">
+                <a:schemeClr val="accent1"/>
+              </a:effectRef>
+              <a:fontRef idx="minor">
+                <a:schemeClr val="lt1"/>
+              </a:fontRef>
+            </p:style>
+            <p:txBody>
+              <a:bodyPr rtlCol="0" anchor="ctr"/>
+              <a:lstStyle/>
+              <a:p>
+                <a:pPr algn="ctr"/>
+                <a:endParaRPr lang="en-US"/>
+              </a:p>
+            </p:txBody>
+          </p:sp>
+        </p:grpSp>
+        <p:grpSp>
+          <p:nvGrpSpPr>
+            <p:cNvPr id="3" name="Group 2">
+              <a:extLst>
+                <a:ext uri="{FF2B5EF4-FFF2-40B4-BE49-F238E27FC236}">
+                  <a16:creationId xmlns:a16="http://schemas.microsoft.com/office/drawing/2014/main" id="{CF54F3C6-E541-849F-0EDB-886867563FF0}"/>
+                </a:ext>
+              </a:extLst>
+            </p:cNvPr>
+            <p:cNvGrpSpPr/>
+            <p:nvPr/>
+          </p:nvGrpSpPr>
+          <p:grpSpPr>
+            <a:xfrm>
+              <a:off x="3531914" y="2055746"/>
+              <a:ext cx="5093985" cy="1371600"/>
+              <a:chOff x="3537058" y="1206044"/>
+              <a:chExt cx="5093985" cy="1371600"/>
+            </a:xfrm>
+          </p:grpSpPr>
+          <p:pic>
+            <p:nvPicPr>
+              <p:cNvPr id="59" name="Picture 58" descr="A graph showing a line&#10;&#10;Description automatically generated with medium confidence">
+                <a:extLst>
+                  <a:ext uri="{FF2B5EF4-FFF2-40B4-BE49-F238E27FC236}">
+                    <a16:creationId xmlns:a16="http://schemas.microsoft.com/office/drawing/2014/main" id="{4F18A0D3-4D6F-7AF3-BAEA-0FF0E2C4E3A0}"/>
+                  </a:ext>
+                </a:extLst>
+              </p:cNvPr>
+              <p:cNvPicPr>
+                <a:picLocks noChangeAspect="1"/>
+              </p:cNvPicPr>
+              <p:nvPr/>
+            </p:nvPicPr>
+            <p:blipFill>
+              <a:blip r:embed="rId5">
+                <a:extLst>
+                  <a:ext uri="{28A0092B-C50C-407E-A947-70E740481C1C}">
+                    <a14:useLocalDpi xmlns:a14="http://schemas.microsoft.com/office/drawing/2010/main" val="0"/>
+                  </a:ext>
+                </a:extLst>
+              </a:blip>
+              <a:stretch>
+                <a:fillRect/>
+              </a:stretch>
+            </p:blipFill>
+            <p:spPr>
+              <a:xfrm>
+                <a:off x="5887843" y="1206044"/>
+                <a:ext cx="2743200" cy="1371600"/>
+              </a:xfrm>
+              <a:prstGeom prst="rect">
+                <a:avLst/>
+              </a:prstGeom>
+            </p:spPr>
+          </p:pic>
           <p:grpSp>
             <p:nvGrpSpPr>
-              <p:cNvPr id="94" name="Group 93">
+              <p:cNvPr id="2" name="Group 1">
                 <a:extLst>
                   <a:ext uri="{FF2B5EF4-FFF2-40B4-BE49-F238E27FC236}">
-                    <a16:creationId xmlns:a16="http://schemas.microsoft.com/office/drawing/2014/main" id="{DF6E3C1C-BEB7-2EAF-6F4A-BD0642020ECC}"/>
+                    <a16:creationId xmlns:a16="http://schemas.microsoft.com/office/drawing/2014/main" id="{ED3E23CA-2CEE-E1D1-31C2-DEBC3F9BAB37}"/>
                   </a:ext>
                 </a:extLst>
               </p:cNvPr>
@@ -3328,10 +3491,10 @@
             </p:nvGrpSpPr>
             <p:grpSpPr>
               <a:xfrm>
-                <a:off x="3148021" y="1211888"/>
-                <a:ext cx="2354003" cy="4279831"/>
-                <a:chOff x="3244120" y="1207096"/>
-                <a:chExt cx="3033811" cy="4279831"/>
+                <a:off x="3537058" y="1437204"/>
+                <a:ext cx="2348844" cy="713184"/>
+                <a:chOff x="3537058" y="1437204"/>
+                <a:chExt cx="2348844" cy="713184"/>
               </a:xfrm>
             </p:grpSpPr>
             <p:grpSp>
@@ -3348,8 +3511,8 @@
               </p:nvGrpSpPr>
               <p:grpSpPr>
                 <a:xfrm>
-                  <a:off x="3250750" y="1207096"/>
-                  <a:ext cx="2743201" cy="713184"/>
+                  <a:off x="3537058" y="1437204"/>
+                  <a:ext cx="2128512" cy="713184"/>
                   <a:chOff x="3174888" y="1268760"/>
                   <a:chExt cx="2999232" cy="713184"/>
                 </a:xfrm>
@@ -3425,167 +3588,6 @@
                 </p:spPr>
               </p:pic>
             </p:grpSp>
-            <p:grpSp>
-              <p:nvGrpSpPr>
-                <p:cNvPr id="55" name="Group 54">
-                  <a:extLst>
-                    <a:ext uri="{FF2B5EF4-FFF2-40B4-BE49-F238E27FC236}">
-                      <a16:creationId xmlns:a16="http://schemas.microsoft.com/office/drawing/2014/main" id="{99DAD50E-7A2B-7192-B6B4-C42B40D55331}"/>
-                    </a:ext>
-                  </a:extLst>
-                </p:cNvPr>
-                <p:cNvGrpSpPr/>
-                <p:nvPr/>
-              </p:nvGrpSpPr>
-              <p:grpSpPr>
-                <a:xfrm>
-                  <a:off x="3260022" y="2837366"/>
-                  <a:ext cx="2743202" cy="736774"/>
-                  <a:chOff x="3064000" y="2379140"/>
-                  <a:chExt cx="3007616" cy="736774"/>
-                </a:xfrm>
-              </p:grpSpPr>
-              <p:pic>
-                <p:nvPicPr>
-                  <p:cNvPr id="53" name="Picture 52" descr="A set of colorful lines&#10;&#10;Description automatically generated with medium confidence">
-                    <a:extLst>
-                      <a:ext uri="{FF2B5EF4-FFF2-40B4-BE49-F238E27FC236}">
-                        <a16:creationId xmlns:a16="http://schemas.microsoft.com/office/drawing/2014/main" id="{4FC52D71-2FE1-0D61-3BC0-8B623942261F}"/>
-                      </a:ext>
-                    </a:extLst>
-                  </p:cNvPr>
-                  <p:cNvPicPr>
-                    <a:picLocks noChangeAspect="1"/>
-                  </p:cNvPicPr>
-                  <p:nvPr/>
-                </p:nvPicPr>
-                <p:blipFill rotWithShape="1">
-                  <a:blip r:embed="rId3">
-                    <a:extLst>
-                      <a:ext uri="{28A0092B-C50C-407E-A947-70E740481C1C}">
-                        <a14:useLocalDpi xmlns:a14="http://schemas.microsoft.com/office/drawing/2010/main" val="0"/>
-                      </a:ext>
-                    </a:extLst>
-                  </a:blip>
-                  <a:srcRect t="6859" b="84446"/>
-                  <a:stretch/>
-                </p:blipFill>
-                <p:spPr>
-                  <a:xfrm>
-                    <a:off x="3072384" y="2379140"/>
-                    <a:ext cx="2999232" cy="356592"/>
-                  </a:xfrm>
-                  <a:prstGeom prst="rect">
-                    <a:avLst/>
-                  </a:prstGeom>
-                </p:spPr>
-              </p:pic>
-              <p:pic>
-                <p:nvPicPr>
-                  <p:cNvPr id="54" name="Picture 53" descr="A set of colorful lines&#10;&#10;Description automatically generated with medium confidence">
-                    <a:extLst>
-                      <a:ext uri="{FF2B5EF4-FFF2-40B4-BE49-F238E27FC236}">
-                        <a16:creationId xmlns:a16="http://schemas.microsoft.com/office/drawing/2014/main" id="{908DEEE1-9B1C-EFCC-4B5F-FC7900478E6E}"/>
-                      </a:ext>
-                    </a:extLst>
-                  </p:cNvPr>
-                  <p:cNvPicPr>
-                    <a:picLocks noChangeAspect="1"/>
-                  </p:cNvPicPr>
-                  <p:nvPr/>
-                </p:nvPicPr>
-                <p:blipFill rotWithShape="1">
-                  <a:blip r:embed="rId3">
-                    <a:extLst>
-                      <a:ext uri="{28A0092B-C50C-407E-A947-70E740481C1C}">
-                        <a14:useLocalDpi xmlns:a14="http://schemas.microsoft.com/office/drawing/2010/main" val="0"/>
-                      </a:ext>
-                    </a:extLst>
-                  </a:blip>
-                  <a:srcRect t="15356" b="75949"/>
-                  <a:stretch/>
-                </p:blipFill>
-                <p:spPr>
-                  <a:xfrm>
-                    <a:off x="3064000" y="2759322"/>
-                    <a:ext cx="2999232" cy="356592"/>
-                  </a:xfrm>
-                  <a:prstGeom prst="rect">
-                    <a:avLst/>
-                  </a:prstGeom>
-                </p:spPr>
-              </p:pic>
-            </p:grpSp>
-            <p:pic>
-              <p:nvPicPr>
-                <p:cNvPr id="56" name="Picture 55" descr="A set of colorful lines&#10;&#10;Description automatically generated with medium confidence">
-                  <a:extLst>
-                    <a:ext uri="{FF2B5EF4-FFF2-40B4-BE49-F238E27FC236}">
-                      <a16:creationId xmlns:a16="http://schemas.microsoft.com/office/drawing/2014/main" id="{E25B4579-A89B-BBE3-0542-187D7C9A9117}"/>
-                    </a:ext>
-                  </a:extLst>
-                </p:cNvPr>
-                <p:cNvPicPr>
-                  <a:picLocks noChangeAspect="1"/>
-                </p:cNvPicPr>
-                <p:nvPr/>
-              </p:nvPicPr>
-              <p:blipFill rotWithShape="1">
-                <a:blip r:embed="rId3">
-                  <a:extLst>
-                    <a:ext uri="{28A0092B-C50C-407E-A947-70E740481C1C}">
-                      <a14:useLocalDpi xmlns:a14="http://schemas.microsoft.com/office/drawing/2010/main" val="0"/>
-                    </a:ext>
-                  </a:extLst>
-                </a:blip>
-                <a:srcRect b="83945"/>
-                <a:stretch/>
-              </p:blipFill>
-              <p:spPr>
-                <a:xfrm>
-                  <a:off x="3252472" y="4189659"/>
-                  <a:ext cx="2735555" cy="658416"/>
-                </a:xfrm>
-                <a:prstGeom prst="rect">
-                  <a:avLst/>
-                </a:prstGeom>
-              </p:spPr>
-            </p:pic>
-            <p:pic>
-              <p:nvPicPr>
-                <p:cNvPr id="57" name="Picture 56" descr="A set of colorful lines&#10;&#10;Description automatically generated with medium confidence">
-                  <a:extLst>
-                    <a:ext uri="{FF2B5EF4-FFF2-40B4-BE49-F238E27FC236}">
-                      <a16:creationId xmlns:a16="http://schemas.microsoft.com/office/drawing/2014/main" id="{184A4771-D284-7615-3F6D-49AC45E1B0A4}"/>
-                    </a:ext>
-                  </a:extLst>
-                </p:cNvPr>
-                <p:cNvPicPr>
-                  <a:picLocks noChangeAspect="1"/>
-                </p:cNvPicPr>
-                <p:nvPr/>
-              </p:nvPicPr>
-              <p:blipFill rotWithShape="1">
-                <a:blip r:embed="rId3">
-                  <a:extLst>
-                    <a:ext uri="{28A0092B-C50C-407E-A947-70E740481C1C}">
-                      <a14:useLocalDpi xmlns:a14="http://schemas.microsoft.com/office/drawing/2010/main" val="0"/>
-                    </a:ext>
-                  </a:extLst>
-                </a:blip>
-                <a:srcRect t="49023" b="35968"/>
-                <a:stretch/>
-              </p:blipFill>
-              <p:spPr>
-                <a:xfrm>
-                  <a:off x="3244120" y="4871408"/>
-                  <a:ext cx="2735555" cy="615519"/>
-                </a:xfrm>
-                <a:prstGeom prst="rect">
-                  <a:avLst/>
-                </a:prstGeom>
-              </p:spPr>
-            </p:pic>
             <p:sp>
               <p:nvSpPr>
                 <p:cNvPr id="85" name="Right Arrow 84">
@@ -3600,8 +3602,8 @@
               </p:nvSpPr>
               <p:spPr>
                 <a:xfrm>
-                  <a:off x="5978568" y="1208643"/>
-                  <a:ext cx="299344" cy="274320"/>
+                  <a:off x="5653634" y="1438751"/>
+                  <a:ext cx="232268" cy="274320"/>
                 </a:xfrm>
                 <a:prstGeom prst="rightArrow">
                   <a:avLst/>
@@ -3654,8 +3656,8 @@
               </p:nvSpPr>
               <p:spPr>
                 <a:xfrm>
-                  <a:off x="5978568" y="1623129"/>
-                  <a:ext cx="299344" cy="173736"/>
+                  <a:off x="5653634" y="1853237"/>
+                  <a:ext cx="232268" cy="173736"/>
                 </a:xfrm>
                 <a:prstGeom prst="rightArrow">
                   <a:avLst/>
@@ -3694,337 +3696,140 @@
                 </a:p>
               </p:txBody>
             </p:sp>
-            <p:sp>
-              <p:nvSpPr>
-                <p:cNvPr id="87" name="Right Arrow 86">
-                  <a:extLst>
-                    <a:ext uri="{FF2B5EF4-FFF2-40B4-BE49-F238E27FC236}">
-                      <a16:creationId xmlns:a16="http://schemas.microsoft.com/office/drawing/2014/main" id="{FCA32D21-A010-E8A2-1053-513A97B98695}"/>
-                    </a:ext>
-                  </a:extLst>
-                </p:cNvPr>
-                <p:cNvSpPr/>
-                <p:nvPr/>
-              </p:nvSpPr>
-              <p:spPr>
-                <a:xfrm>
-                  <a:off x="5978512" y="2928794"/>
-                  <a:ext cx="299344" cy="173736"/>
-                </a:xfrm>
-                <a:prstGeom prst="rightArrow">
-                  <a:avLst/>
-                </a:prstGeom>
-                <a:solidFill>
-                  <a:srgbClr val="00496F"/>
-                </a:solidFill>
-                <a:ln w="3175">
-                  <a:solidFill>
-                    <a:schemeClr val="tx1"/>
-                  </a:solidFill>
-                </a:ln>
-              </p:spPr>
-              <p:style>
-                <a:lnRef idx="2">
-                  <a:schemeClr val="accent1">
-                    <a:shade val="15000"/>
-                  </a:schemeClr>
-                </a:lnRef>
-                <a:fillRef idx="1">
-                  <a:schemeClr val="accent1"/>
-                </a:fillRef>
-                <a:effectRef idx="0">
-                  <a:schemeClr val="accent1"/>
-                </a:effectRef>
-                <a:fontRef idx="minor">
-                  <a:schemeClr val="lt1"/>
-                </a:fontRef>
-              </p:style>
-              <p:txBody>
-                <a:bodyPr rtlCol="0" anchor="ctr"/>
-                <a:lstStyle/>
-                <a:p>
-                  <a:pPr algn="ctr"/>
-                  <a:endParaRPr lang="en-US"/>
-                </a:p>
-              </p:txBody>
-            </p:sp>
-            <p:sp>
-              <p:nvSpPr>
-                <p:cNvPr id="88" name="Right Arrow 87">
-                  <a:extLst>
-                    <a:ext uri="{FF2B5EF4-FFF2-40B4-BE49-F238E27FC236}">
-                      <a16:creationId xmlns:a16="http://schemas.microsoft.com/office/drawing/2014/main" id="{8824C285-2611-8FF9-70B2-10C200B339F9}"/>
-                    </a:ext>
-                  </a:extLst>
-                </p:cNvPr>
-                <p:cNvSpPr/>
-                <p:nvPr/>
-              </p:nvSpPr>
-              <p:spPr>
-                <a:xfrm>
-                  <a:off x="5970056" y="3373713"/>
-                  <a:ext cx="299344" cy="73152"/>
-                </a:xfrm>
-                <a:prstGeom prst="rightArrow">
-                  <a:avLst/>
-                </a:prstGeom>
-                <a:solidFill>
-                  <a:srgbClr val="0C7996"/>
-                </a:solidFill>
-                <a:ln w="3175">
-                  <a:solidFill>
-                    <a:schemeClr val="tx1"/>
-                  </a:solidFill>
-                </a:ln>
-              </p:spPr>
-              <p:style>
-                <a:lnRef idx="2">
-                  <a:schemeClr val="accent1">
-                    <a:shade val="15000"/>
-                  </a:schemeClr>
-                </a:lnRef>
-                <a:fillRef idx="1">
-                  <a:schemeClr val="accent1"/>
-                </a:fillRef>
-                <a:effectRef idx="0">
-                  <a:schemeClr val="accent1"/>
-                </a:effectRef>
-                <a:fontRef idx="minor">
-                  <a:schemeClr val="lt1"/>
-                </a:fontRef>
-              </p:style>
-              <p:txBody>
-                <a:bodyPr rtlCol="0" anchor="ctr"/>
-                <a:lstStyle/>
-                <a:p>
-                  <a:pPr algn="ctr"/>
-                  <a:endParaRPr lang="en-US"/>
-                </a:p>
-              </p:txBody>
-            </p:sp>
-            <p:sp>
-              <p:nvSpPr>
-                <p:cNvPr id="89" name="Right Arrow 88">
-                  <a:extLst>
-                    <a:ext uri="{FF2B5EF4-FFF2-40B4-BE49-F238E27FC236}">
-                      <a16:creationId xmlns:a16="http://schemas.microsoft.com/office/drawing/2014/main" id="{234E50D9-1BAF-098C-89FC-B13225B68B2B}"/>
-                    </a:ext>
-                  </a:extLst>
-                </p:cNvPr>
-                <p:cNvSpPr/>
-                <p:nvPr/>
-              </p:nvSpPr>
-              <p:spPr>
-                <a:xfrm>
-                  <a:off x="5978512" y="4188727"/>
-                  <a:ext cx="299344" cy="274320"/>
-                </a:xfrm>
-                <a:prstGeom prst="rightArrow">
-                  <a:avLst/>
-                </a:prstGeom>
-                <a:solidFill>
-                  <a:srgbClr val="00496F"/>
-                </a:solidFill>
-                <a:ln w="3175">
-                  <a:solidFill>
-                    <a:schemeClr val="tx1"/>
-                  </a:solidFill>
-                </a:ln>
-              </p:spPr>
-              <p:style>
-                <a:lnRef idx="2">
-                  <a:schemeClr val="accent1">
-                    <a:shade val="15000"/>
-                  </a:schemeClr>
-                </a:lnRef>
-                <a:fillRef idx="1">
-                  <a:schemeClr val="accent1"/>
-                </a:fillRef>
-                <a:effectRef idx="0">
-                  <a:schemeClr val="accent1"/>
-                </a:effectRef>
-                <a:fontRef idx="minor">
-                  <a:schemeClr val="lt1"/>
-                </a:fontRef>
-              </p:style>
-              <p:txBody>
-                <a:bodyPr rtlCol="0" anchor="ctr"/>
-                <a:lstStyle/>
-                <a:p>
-                  <a:pPr algn="ctr"/>
-                  <a:endParaRPr lang="en-US"/>
-                </a:p>
-              </p:txBody>
-            </p:sp>
-            <p:sp>
-              <p:nvSpPr>
-                <p:cNvPr id="91" name="Right Arrow 90">
-                  <a:extLst>
-                    <a:ext uri="{FF2B5EF4-FFF2-40B4-BE49-F238E27FC236}">
-                      <a16:creationId xmlns:a16="http://schemas.microsoft.com/office/drawing/2014/main" id="{14E1EBDB-0F05-B4AC-8EDA-B7A3BAFAA3F8}"/>
-                    </a:ext>
-                  </a:extLst>
-                </p:cNvPr>
-                <p:cNvSpPr/>
-                <p:nvPr/>
-              </p:nvSpPr>
-              <p:spPr>
-                <a:xfrm>
-                  <a:off x="5970056" y="4623761"/>
-                  <a:ext cx="299344" cy="73152"/>
-                </a:xfrm>
-                <a:prstGeom prst="rightArrow">
-                  <a:avLst/>
-                </a:prstGeom>
-                <a:solidFill>
-                  <a:srgbClr val="00496F"/>
-                </a:solidFill>
-                <a:ln w="3175">
-                  <a:solidFill>
-                    <a:schemeClr val="tx1"/>
-                  </a:solidFill>
-                </a:ln>
-              </p:spPr>
-              <p:style>
-                <a:lnRef idx="2">
-                  <a:schemeClr val="accent1">
-                    <a:shade val="15000"/>
-                  </a:schemeClr>
-                </a:lnRef>
-                <a:fillRef idx="1">
-                  <a:schemeClr val="accent1"/>
-                </a:fillRef>
-                <a:effectRef idx="0">
-                  <a:schemeClr val="accent1"/>
-                </a:effectRef>
-                <a:fontRef idx="minor">
-                  <a:schemeClr val="lt1"/>
-                </a:fontRef>
-              </p:style>
-              <p:txBody>
-                <a:bodyPr rtlCol="0" anchor="ctr"/>
-                <a:lstStyle/>
-                <a:p>
-                  <a:pPr algn="ctr"/>
-                  <a:endParaRPr lang="en-US"/>
-                </a:p>
-              </p:txBody>
-            </p:sp>
-            <p:sp>
-              <p:nvSpPr>
-                <p:cNvPr id="92" name="Right Arrow 91">
-                  <a:extLst>
-                    <a:ext uri="{FF2B5EF4-FFF2-40B4-BE49-F238E27FC236}">
-                      <a16:creationId xmlns:a16="http://schemas.microsoft.com/office/drawing/2014/main" id="{528F1F8F-A9B5-2127-A0F1-5D2807EBE780}"/>
-                    </a:ext>
-                  </a:extLst>
-                </p:cNvPr>
-                <p:cNvSpPr/>
-                <p:nvPr/>
-              </p:nvSpPr>
-              <p:spPr>
-                <a:xfrm>
-                  <a:off x="5968456" y="4903898"/>
-                  <a:ext cx="299344" cy="173736"/>
-                </a:xfrm>
-                <a:prstGeom prst="rightArrow">
-                  <a:avLst/>
-                </a:prstGeom>
-                <a:solidFill>
-                  <a:srgbClr val="EDB829"/>
-                </a:solidFill>
-                <a:ln w="3175">
-                  <a:solidFill>
-                    <a:schemeClr val="tx1"/>
-                  </a:solidFill>
-                </a:ln>
-              </p:spPr>
-              <p:style>
-                <a:lnRef idx="2">
-                  <a:schemeClr val="accent1">
-                    <a:shade val="15000"/>
-                  </a:schemeClr>
-                </a:lnRef>
-                <a:fillRef idx="1">
-                  <a:schemeClr val="accent1"/>
-                </a:fillRef>
-                <a:effectRef idx="0">
-                  <a:schemeClr val="accent1"/>
-                </a:effectRef>
-                <a:fontRef idx="minor">
-                  <a:schemeClr val="lt1"/>
-                </a:fontRef>
-              </p:style>
-              <p:txBody>
-                <a:bodyPr rtlCol="0" anchor="ctr"/>
-                <a:lstStyle/>
-                <a:p>
-                  <a:pPr algn="ctr"/>
-                  <a:endParaRPr lang="en-US"/>
-                </a:p>
-              </p:txBody>
-            </p:sp>
-            <p:sp>
-              <p:nvSpPr>
-                <p:cNvPr id="93" name="Right Arrow 92">
-                  <a:extLst>
-                    <a:ext uri="{FF2B5EF4-FFF2-40B4-BE49-F238E27FC236}">
-                      <a16:creationId xmlns:a16="http://schemas.microsoft.com/office/drawing/2014/main" id="{CCA42299-8E3B-CA5B-0CE7-82509B938F2B}"/>
-                    </a:ext>
-                  </a:extLst>
-                </p:cNvPr>
-                <p:cNvSpPr/>
-                <p:nvPr/>
-              </p:nvSpPr>
-              <p:spPr>
-                <a:xfrm>
-                  <a:off x="5978587" y="5222498"/>
-                  <a:ext cx="299344" cy="210312"/>
-                </a:xfrm>
-                <a:prstGeom prst="rightArrow">
-                  <a:avLst/>
-                </a:prstGeom>
-                <a:solidFill>
-                  <a:srgbClr val="EDB829"/>
-                </a:solidFill>
-                <a:ln w="3175">
-                  <a:solidFill>
-                    <a:srgbClr val="C00000"/>
-                  </a:solidFill>
-                </a:ln>
-              </p:spPr>
-              <p:style>
-                <a:lnRef idx="2">
-                  <a:schemeClr val="accent1">
-                    <a:shade val="15000"/>
-                  </a:schemeClr>
-                </a:lnRef>
-                <a:fillRef idx="1">
-                  <a:schemeClr val="accent1"/>
-                </a:fillRef>
-                <a:effectRef idx="0">
-                  <a:schemeClr val="accent1"/>
-                </a:effectRef>
-                <a:fontRef idx="minor">
-                  <a:schemeClr val="lt1"/>
-                </a:fontRef>
-              </p:style>
-              <p:txBody>
-                <a:bodyPr rtlCol="0" anchor="ctr"/>
-                <a:lstStyle/>
-                <a:p>
-                  <a:pPr algn="ctr"/>
-                  <a:endParaRPr lang="en-US"/>
-                </a:p>
-              </p:txBody>
-            </p:sp>
           </p:grpSp>
+        </p:grpSp>
+        <p:grpSp>
+          <p:nvGrpSpPr>
+            <p:cNvPr id="6" name="Group 5">
+              <a:extLst>
+                <a:ext uri="{FF2B5EF4-FFF2-40B4-BE49-F238E27FC236}">
+                  <a16:creationId xmlns:a16="http://schemas.microsoft.com/office/drawing/2014/main" id="{F91089BB-49C6-D7C8-678F-2F144AD6AD6C}"/>
+                </a:ext>
+              </a:extLst>
+            </p:cNvPr>
+            <p:cNvGrpSpPr/>
+            <p:nvPr/>
+          </p:nvGrpSpPr>
+          <p:grpSpPr>
+            <a:xfrm>
+              <a:off x="3531914" y="4522727"/>
+              <a:ext cx="5106102" cy="1498561"/>
+              <a:chOff x="3531914" y="4418835"/>
+              <a:chExt cx="5106102" cy="1498561"/>
+            </a:xfrm>
+          </p:grpSpPr>
+          <p:pic>
+            <p:nvPicPr>
+              <p:cNvPr id="63" name="Picture 62" descr="A graph showing a line of time&#10;&#10;Description automatically generated">
+                <a:extLst>
+                  <a:ext uri="{FF2B5EF4-FFF2-40B4-BE49-F238E27FC236}">
+                    <a16:creationId xmlns:a16="http://schemas.microsoft.com/office/drawing/2014/main" id="{4670FD12-50CE-503B-BAA7-F976D5EA3117}"/>
+                  </a:ext>
+                </a:extLst>
+              </p:cNvPr>
+              <p:cNvPicPr>
+                <a:picLocks noChangeAspect="1"/>
+              </p:cNvPicPr>
+              <p:nvPr/>
+            </p:nvPicPr>
+            <p:blipFill>
+              <a:blip r:embed="rId6">
+                <a:extLst>
+                  <a:ext uri="{28A0092B-C50C-407E-A947-70E740481C1C}">
+                    <a14:useLocalDpi xmlns:a14="http://schemas.microsoft.com/office/drawing/2010/main" val="0"/>
+                  </a:ext>
+                </a:extLst>
+              </a:blip>
+              <a:stretch>
+                <a:fillRect/>
+              </a:stretch>
+            </p:blipFill>
+            <p:spPr>
+              <a:xfrm>
+                <a:off x="5894816" y="4545796"/>
+                <a:ext cx="2743200" cy="1371600"/>
+              </a:xfrm>
+              <a:prstGeom prst="rect">
+                <a:avLst/>
+              </a:prstGeom>
+            </p:spPr>
+          </p:pic>
+          <p:pic>
+            <p:nvPicPr>
+              <p:cNvPr id="56" name="Picture 55" descr="A set of colorful lines&#10;&#10;Description automatically generated with medium confidence">
+                <a:extLst>
+                  <a:ext uri="{FF2B5EF4-FFF2-40B4-BE49-F238E27FC236}">
+                    <a16:creationId xmlns:a16="http://schemas.microsoft.com/office/drawing/2014/main" id="{E25B4579-A89B-BBE3-0542-187D7C9A9117}"/>
+                  </a:ext>
+                </a:extLst>
+              </p:cNvPr>
+              <p:cNvPicPr>
+                <a:picLocks noChangeAspect="1"/>
+              </p:cNvPicPr>
+              <p:nvPr/>
+            </p:nvPicPr>
+            <p:blipFill rotWithShape="1">
+              <a:blip r:embed="rId3">
+                <a:extLst>
+                  <a:ext uri="{28A0092B-C50C-407E-A947-70E740481C1C}">
+                    <a14:useLocalDpi xmlns:a14="http://schemas.microsoft.com/office/drawing/2010/main" val="0"/>
+                  </a:ext>
+                </a:extLst>
+              </a:blip>
+              <a:srcRect b="83945"/>
+              <a:stretch/>
+            </p:blipFill>
+            <p:spPr>
+              <a:xfrm>
+                <a:off x="3538395" y="4419767"/>
+                <a:ext cx="2122579" cy="658416"/>
+              </a:xfrm>
+              <a:prstGeom prst="rect">
+                <a:avLst/>
+              </a:prstGeom>
+            </p:spPr>
+          </p:pic>
+          <p:pic>
+            <p:nvPicPr>
+              <p:cNvPr id="57" name="Picture 56" descr="A set of colorful lines&#10;&#10;Description automatically generated with medium confidence">
+                <a:extLst>
+                  <a:ext uri="{FF2B5EF4-FFF2-40B4-BE49-F238E27FC236}">
+                    <a16:creationId xmlns:a16="http://schemas.microsoft.com/office/drawing/2014/main" id="{184A4771-D284-7615-3F6D-49AC45E1B0A4}"/>
+                  </a:ext>
+                </a:extLst>
+              </p:cNvPr>
+              <p:cNvPicPr>
+                <a:picLocks noChangeAspect="1"/>
+              </p:cNvPicPr>
+              <p:nvPr/>
+            </p:nvPicPr>
+            <p:blipFill rotWithShape="1">
+              <a:blip r:embed="rId3">
+                <a:extLst>
+                  <a:ext uri="{28A0092B-C50C-407E-A947-70E740481C1C}">
+                    <a14:useLocalDpi xmlns:a14="http://schemas.microsoft.com/office/drawing/2010/main" val="0"/>
+                  </a:ext>
+                </a:extLst>
+              </a:blip>
+              <a:srcRect t="49023" b="35968"/>
+              <a:stretch/>
+            </p:blipFill>
+            <p:spPr>
+              <a:xfrm>
+                <a:off x="3531914" y="5101516"/>
+                <a:ext cx="2122579" cy="615519"/>
+              </a:xfrm>
+              <a:prstGeom prst="rect">
+                <a:avLst/>
+              </a:prstGeom>
+            </p:spPr>
+          </p:pic>
           <p:sp>
             <p:nvSpPr>
-              <p:cNvPr id="96" name="Rectangle 95">
+              <p:cNvPr id="89" name="Right Arrow 88">
                 <a:extLst>
                   <a:ext uri="{FF2B5EF4-FFF2-40B4-BE49-F238E27FC236}">
-                    <a16:creationId xmlns:a16="http://schemas.microsoft.com/office/drawing/2014/main" id="{C8F054CC-BF9A-0A53-8CF7-E6C7FC00949B}"/>
+                    <a16:creationId xmlns:a16="http://schemas.microsoft.com/office/drawing/2014/main" id="{234E50D9-1BAF-098C-89FC-B13225B68B2B}"/>
                   </a:ext>
                 </a:extLst>
               </p:cNvPr>
@@ -4033,14 +3838,16 @@
             </p:nvSpPr>
             <p:spPr>
               <a:xfrm>
-                <a:off x="251520" y="404664"/>
-                <a:ext cx="2872629" cy="5760640"/>
+                <a:off x="5653591" y="4418835"/>
+                <a:ext cx="232268" cy="274320"/>
               </a:xfrm>
-              <a:prstGeom prst="rect">
+              <a:prstGeom prst="rightArrow">
                 <a:avLst/>
               </a:prstGeom>
-              <a:noFill/>
-              <a:ln>
+              <a:solidFill>
+                <a:srgbClr val="00496F"/>
+              </a:solidFill>
+              <a:ln w="3175">
                 <a:solidFill>
                   <a:schemeClr val="tx1"/>
                 </a:solidFill>
@@ -4073,48 +3880,10 @@
           </p:sp>
           <p:sp>
             <p:nvSpPr>
-              <p:cNvPr id="97" name="TextBox 96">
+              <p:cNvPr id="91" name="Right Arrow 90">
                 <a:extLst>
                   <a:ext uri="{FF2B5EF4-FFF2-40B4-BE49-F238E27FC236}">
-                    <a16:creationId xmlns:a16="http://schemas.microsoft.com/office/drawing/2014/main" id="{9543B056-7D7B-0389-6F20-CF9C830C2F6D}"/>
-                  </a:ext>
-                </a:extLst>
-              </p:cNvPr>
-              <p:cNvSpPr txBox="1"/>
-              <p:nvPr/>
-            </p:nvSpPr>
-            <p:spPr>
-              <a:xfrm>
-                <a:off x="160231" y="35332"/>
-                <a:ext cx="1980029" cy="369332"/>
-              </a:xfrm>
-              <a:prstGeom prst="rect">
-                <a:avLst/>
-              </a:prstGeom>
-              <a:noFill/>
-            </p:spPr>
-            <p:txBody>
-              <a:bodyPr wrap="none" rtlCol="0">
-                <a:spAutoFit/>
-              </a:bodyPr>
-              <a:lstStyle/>
-              <a:p>
-                <a:r>
-                  <a:rPr lang="en-US" dirty="0">
-                    <a:latin typeface="Helvetica" pitchFamily="2" charset="0"/>
-                    <a:cs typeface="Arial" panose="020B0604020202020204" pitchFamily="34" charset="0"/>
-                  </a:rPr>
-                  <a:t>a) Decomposition</a:t>
-                </a:r>
-              </a:p>
-            </p:txBody>
-          </p:sp>
-          <p:sp>
-            <p:nvSpPr>
-              <p:cNvPr id="98" name="Rectangle 97">
-                <a:extLst>
-                  <a:ext uri="{FF2B5EF4-FFF2-40B4-BE49-F238E27FC236}">
-                    <a16:creationId xmlns:a16="http://schemas.microsoft.com/office/drawing/2014/main" id="{31DBBBD3-F7E7-757D-70E4-4D5D85D9815C}"/>
+                    <a16:creationId xmlns:a16="http://schemas.microsoft.com/office/drawing/2014/main" id="{14E1EBDB-0F05-B4AC-8EDA-B7A3BAFAA3F8}"/>
                   </a:ext>
                 </a:extLst>
               </p:cNvPr>
@@ -4123,14 +3892,16 @@
             </p:nvSpPr>
             <p:spPr>
               <a:xfrm>
-                <a:off x="3253579" y="404664"/>
-                <a:ext cx="5000544" cy="5760640"/>
+                <a:off x="5647030" y="4853869"/>
+                <a:ext cx="232268" cy="73152"/>
               </a:xfrm>
-              <a:prstGeom prst="rect">
+              <a:prstGeom prst="rightArrow">
                 <a:avLst/>
               </a:prstGeom>
-              <a:noFill/>
-              <a:ln>
+              <a:solidFill>
+                <a:srgbClr val="00496F"/>
+              </a:solidFill>
+              <a:ln w="3175">
                 <a:solidFill>
                   <a:schemeClr val="tx1"/>
                 </a:solidFill>
@@ -4163,43 +3934,384 @@
           </p:sp>
           <p:sp>
             <p:nvSpPr>
-              <p:cNvPr id="99" name="TextBox 98">
+              <p:cNvPr id="92" name="Right Arrow 91">
                 <a:extLst>
                   <a:ext uri="{FF2B5EF4-FFF2-40B4-BE49-F238E27FC236}">
-                    <a16:creationId xmlns:a16="http://schemas.microsoft.com/office/drawing/2014/main" id="{48CF7F87-F487-0602-8884-FE9FE6E3A1BD}"/>
+                    <a16:creationId xmlns:a16="http://schemas.microsoft.com/office/drawing/2014/main" id="{528F1F8F-A9B5-2127-A0F1-5D2807EBE780}"/>
                   </a:ext>
                 </a:extLst>
               </p:cNvPr>
-              <p:cNvSpPr txBox="1"/>
+              <p:cNvSpPr/>
               <p:nvPr/>
             </p:nvSpPr>
             <p:spPr>
               <a:xfrm>
-                <a:off x="3219295" y="35332"/>
-                <a:ext cx="2518638" cy="369332"/>
+                <a:off x="5645788" y="5134006"/>
+                <a:ext cx="232268" cy="173736"/>
               </a:xfrm>
-              <a:prstGeom prst="rect">
+              <a:prstGeom prst="rightArrow">
                 <a:avLst/>
               </a:prstGeom>
-              <a:noFill/>
+              <a:solidFill>
+                <a:srgbClr val="EDB829"/>
+              </a:solidFill>
+              <a:ln w="3175">
+                <a:solidFill>
+                  <a:schemeClr val="tx1"/>
+                </a:solidFill>
+              </a:ln>
             </p:spPr>
+            <p:style>
+              <a:lnRef idx="2">
+                <a:schemeClr val="accent1">
+                  <a:shade val="15000"/>
+                </a:schemeClr>
+              </a:lnRef>
+              <a:fillRef idx="1">
+                <a:schemeClr val="accent1"/>
+              </a:fillRef>
+              <a:effectRef idx="0">
+                <a:schemeClr val="accent1"/>
+              </a:effectRef>
+              <a:fontRef idx="minor">
+                <a:schemeClr val="lt1"/>
+              </a:fontRef>
+            </p:style>
             <p:txBody>
-              <a:bodyPr wrap="none" rtlCol="0">
-                <a:spAutoFit/>
-              </a:bodyPr>
+              <a:bodyPr rtlCol="0" anchor="ctr"/>
               <a:lstStyle/>
               <a:p>
-                <a:r>
-                  <a:rPr lang="en-US" dirty="0">
-                    <a:latin typeface="Helvetica" pitchFamily="2" charset="0"/>
-                    <a:cs typeface="Arial" panose="020B0604020202020204" pitchFamily="34" charset="0"/>
-                  </a:rPr>
-                  <a:t>b) Linear combinations</a:t>
-                </a:r>
+                <a:pPr algn="ctr"/>
+                <a:endParaRPr lang="en-US"/>
+              </a:p>
+            </p:txBody>
+          </p:sp>
+          <p:sp>
+            <p:nvSpPr>
+              <p:cNvPr id="93" name="Right Arrow 92">
+                <a:extLst>
+                  <a:ext uri="{FF2B5EF4-FFF2-40B4-BE49-F238E27FC236}">
+                    <a16:creationId xmlns:a16="http://schemas.microsoft.com/office/drawing/2014/main" id="{CCA42299-8E3B-CA5B-0CE7-82509B938F2B}"/>
+                  </a:ext>
+                </a:extLst>
+              </p:cNvPr>
+              <p:cNvSpPr/>
+              <p:nvPr/>
+            </p:nvSpPr>
+            <p:spPr>
+              <a:xfrm>
+                <a:off x="5653649" y="5452606"/>
+                <a:ext cx="232268" cy="210312"/>
+              </a:xfrm>
+              <a:prstGeom prst="rightArrow">
+                <a:avLst/>
+              </a:prstGeom>
+              <a:solidFill>
+                <a:srgbClr val="EDB829"/>
+              </a:solidFill>
+              <a:ln w="15875">
+                <a:solidFill>
+                  <a:srgbClr val="C00000"/>
+                </a:solidFill>
+              </a:ln>
+            </p:spPr>
+            <p:style>
+              <a:lnRef idx="2">
+                <a:schemeClr val="accent1">
+                  <a:shade val="15000"/>
+                </a:schemeClr>
+              </a:lnRef>
+              <a:fillRef idx="1">
+                <a:schemeClr val="accent1"/>
+              </a:fillRef>
+              <a:effectRef idx="0">
+                <a:schemeClr val="accent1"/>
+              </a:effectRef>
+              <a:fontRef idx="minor">
+                <a:schemeClr val="lt1"/>
+              </a:fontRef>
+            </p:style>
+            <p:txBody>
+              <a:bodyPr rtlCol="0" anchor="ctr"/>
+              <a:lstStyle/>
+              <a:p>
+                <a:pPr algn="ctr"/>
+                <a:endParaRPr lang="en-US"/>
               </a:p>
             </p:txBody>
           </p:sp>
         </p:grpSp>
+        <p:sp>
+          <p:nvSpPr>
+            <p:cNvPr id="96" name="Rectangle 95">
+              <a:extLst>
+                <a:ext uri="{FF2B5EF4-FFF2-40B4-BE49-F238E27FC236}">
+                  <a16:creationId xmlns:a16="http://schemas.microsoft.com/office/drawing/2014/main" id="{C8F054CC-BF9A-0A53-8CF7-E6C7FC00949B}"/>
+                </a:ext>
+              </a:extLst>
+            </p:cNvPr>
+            <p:cNvSpPr/>
+            <p:nvPr/>
+          </p:nvSpPr>
+          <p:spPr>
+            <a:xfrm>
+              <a:off x="635413" y="629980"/>
+              <a:ext cx="2872629" cy="5760640"/>
+            </a:xfrm>
+            <a:prstGeom prst="rect">
+              <a:avLst/>
+            </a:prstGeom>
+            <a:noFill/>
+            <a:ln>
+              <a:solidFill>
+                <a:schemeClr val="tx1"/>
+              </a:solidFill>
+            </a:ln>
+          </p:spPr>
+          <p:style>
+            <a:lnRef idx="2">
+              <a:schemeClr val="accent1">
+                <a:shade val="15000"/>
+              </a:schemeClr>
+            </a:lnRef>
+            <a:fillRef idx="1">
+              <a:schemeClr val="accent1"/>
+            </a:fillRef>
+            <a:effectRef idx="0">
+              <a:schemeClr val="accent1"/>
+            </a:effectRef>
+            <a:fontRef idx="minor">
+              <a:schemeClr val="lt1"/>
+            </a:fontRef>
+          </p:style>
+          <p:txBody>
+            <a:bodyPr rtlCol="0" anchor="ctr"/>
+            <a:lstStyle/>
+            <a:p>
+              <a:pPr algn="ctr"/>
+              <a:endParaRPr lang="en-US"/>
+            </a:p>
+          </p:txBody>
+        </p:sp>
+        <p:sp>
+          <p:nvSpPr>
+            <p:cNvPr id="97" name="TextBox 96">
+              <a:extLst>
+                <a:ext uri="{FF2B5EF4-FFF2-40B4-BE49-F238E27FC236}">
+                  <a16:creationId xmlns:a16="http://schemas.microsoft.com/office/drawing/2014/main" id="{9543B056-7D7B-0389-6F20-CF9C830C2F6D}"/>
+                </a:ext>
+              </a:extLst>
+            </p:cNvPr>
+            <p:cNvSpPr txBox="1"/>
+            <p:nvPr/>
+          </p:nvSpPr>
+          <p:spPr>
+            <a:xfrm>
+              <a:off x="544124" y="260648"/>
+              <a:ext cx="1980029" cy="369332"/>
+            </a:xfrm>
+            <a:prstGeom prst="rect">
+              <a:avLst/>
+            </a:prstGeom>
+            <a:noFill/>
+          </p:spPr>
+          <p:txBody>
+            <a:bodyPr wrap="square" rtlCol="0">
+              <a:spAutoFit/>
+            </a:bodyPr>
+            <a:lstStyle/>
+            <a:p>
+              <a:r>
+                <a:rPr lang="en-US" dirty="0">
+                  <a:latin typeface="Helvetica" pitchFamily="2" charset="0"/>
+                  <a:cs typeface="Arial" panose="020B0604020202020204" pitchFamily="34" charset="0"/>
+                </a:rPr>
+                <a:t>a) Decomposition</a:t>
+              </a:r>
+            </a:p>
+          </p:txBody>
+        </p:sp>
+        <p:sp>
+          <p:nvSpPr>
+            <p:cNvPr id="98" name="Rectangle 97">
+              <a:extLst>
+                <a:ext uri="{FF2B5EF4-FFF2-40B4-BE49-F238E27FC236}">
+                  <a16:creationId xmlns:a16="http://schemas.microsoft.com/office/drawing/2014/main" id="{31DBBBD3-F7E7-757D-70E4-4D5D85D9815C}"/>
+                </a:ext>
+              </a:extLst>
+            </p:cNvPr>
+            <p:cNvSpPr/>
+            <p:nvPr/>
+          </p:nvSpPr>
+          <p:spPr>
+            <a:xfrm>
+              <a:off x="3637472" y="629980"/>
+              <a:ext cx="5000544" cy="2797366"/>
+            </a:xfrm>
+            <a:prstGeom prst="rect">
+              <a:avLst/>
+            </a:prstGeom>
+            <a:noFill/>
+            <a:ln>
+              <a:solidFill>
+                <a:schemeClr val="tx1"/>
+              </a:solidFill>
+            </a:ln>
+          </p:spPr>
+          <p:style>
+            <a:lnRef idx="2">
+              <a:schemeClr val="accent1">
+                <a:shade val="15000"/>
+              </a:schemeClr>
+            </a:lnRef>
+            <a:fillRef idx="1">
+              <a:schemeClr val="accent1"/>
+            </a:fillRef>
+            <a:effectRef idx="0">
+              <a:schemeClr val="accent1"/>
+            </a:effectRef>
+            <a:fontRef idx="minor">
+              <a:schemeClr val="lt1"/>
+            </a:fontRef>
+          </p:style>
+          <p:txBody>
+            <a:bodyPr rtlCol="0" anchor="ctr"/>
+            <a:lstStyle/>
+            <a:p>
+              <a:pPr algn="ctr"/>
+              <a:endParaRPr lang="en-US"/>
+            </a:p>
+          </p:txBody>
+        </p:sp>
+        <p:sp>
+          <p:nvSpPr>
+            <p:cNvPr id="99" name="TextBox 98">
+              <a:extLst>
+                <a:ext uri="{FF2B5EF4-FFF2-40B4-BE49-F238E27FC236}">
+                  <a16:creationId xmlns:a16="http://schemas.microsoft.com/office/drawing/2014/main" id="{48CF7F87-F487-0602-8884-FE9FE6E3A1BD}"/>
+                </a:ext>
+              </a:extLst>
+            </p:cNvPr>
+            <p:cNvSpPr txBox="1"/>
+            <p:nvPr/>
+          </p:nvSpPr>
+          <p:spPr>
+            <a:xfrm>
+              <a:off x="3603188" y="260648"/>
+              <a:ext cx="3463128" cy="369332"/>
+            </a:xfrm>
+            <a:prstGeom prst="rect">
+              <a:avLst/>
+            </a:prstGeom>
+            <a:noFill/>
+          </p:spPr>
+          <p:txBody>
+            <a:bodyPr wrap="square" rtlCol="0">
+              <a:spAutoFit/>
+            </a:bodyPr>
+            <a:lstStyle/>
+            <a:p>
+              <a:pPr marL="7938"/>
+              <a:r>
+                <a:rPr lang="en-US" dirty="0">
+                  <a:latin typeface="Helvetica" pitchFamily="2" charset="0"/>
+                  <a:cs typeface="Arial" panose="020B0604020202020204" pitchFamily="34" charset="0"/>
+                </a:rPr>
+                <a:t>b) Possible linear combinations</a:t>
+              </a:r>
+            </a:p>
+          </p:txBody>
+        </p:sp>
+        <p:sp>
+          <p:nvSpPr>
+            <p:cNvPr id="5" name="Rectangle 4">
+              <a:extLst>
+                <a:ext uri="{FF2B5EF4-FFF2-40B4-BE49-F238E27FC236}">
+                  <a16:creationId xmlns:a16="http://schemas.microsoft.com/office/drawing/2014/main" id="{0D3510E5-2004-BD9B-4CF0-F44B24150994}"/>
+                </a:ext>
+              </a:extLst>
+            </p:cNvPr>
+            <p:cNvSpPr/>
+            <p:nvPr/>
+          </p:nvSpPr>
+          <p:spPr>
+            <a:xfrm>
+              <a:off x="3652403" y="4034859"/>
+              <a:ext cx="5000544" cy="2358294"/>
+            </a:xfrm>
+            <a:prstGeom prst="rect">
+              <a:avLst/>
+            </a:prstGeom>
+            <a:noFill/>
+            <a:ln>
+              <a:solidFill>
+                <a:schemeClr val="tx1"/>
+              </a:solidFill>
+            </a:ln>
+          </p:spPr>
+          <p:style>
+            <a:lnRef idx="2">
+              <a:schemeClr val="accent1">
+                <a:shade val="15000"/>
+              </a:schemeClr>
+            </a:lnRef>
+            <a:fillRef idx="1">
+              <a:schemeClr val="accent1"/>
+            </a:fillRef>
+            <a:effectRef idx="0">
+              <a:schemeClr val="accent1"/>
+            </a:effectRef>
+            <a:fontRef idx="minor">
+              <a:schemeClr val="lt1"/>
+            </a:fontRef>
+          </p:style>
+          <p:txBody>
+            <a:bodyPr rtlCol="0" anchor="ctr"/>
+            <a:lstStyle/>
+            <a:p>
+              <a:pPr algn="ctr"/>
+              <a:endParaRPr lang="en-US"/>
+            </a:p>
+          </p:txBody>
+        </p:sp>
+        <p:sp>
+          <p:nvSpPr>
+            <p:cNvPr id="7" name="TextBox 6">
+              <a:extLst>
+                <a:ext uri="{FF2B5EF4-FFF2-40B4-BE49-F238E27FC236}">
+                  <a16:creationId xmlns:a16="http://schemas.microsoft.com/office/drawing/2014/main" id="{982298F3-2624-FF75-8CDA-577D01C92BE0}"/>
+                </a:ext>
+              </a:extLst>
+            </p:cNvPr>
+            <p:cNvSpPr txBox="1"/>
+            <p:nvPr/>
+          </p:nvSpPr>
+          <p:spPr>
+            <a:xfrm>
+              <a:off x="3621575" y="3637616"/>
+              <a:ext cx="2467342" cy="369332"/>
+            </a:xfrm>
+            <a:prstGeom prst="rect">
+              <a:avLst/>
+            </a:prstGeom>
+            <a:noFill/>
+          </p:spPr>
+          <p:txBody>
+            <a:bodyPr wrap="square" rtlCol="0">
+              <a:spAutoFit/>
+            </a:bodyPr>
+            <a:lstStyle/>
+            <a:p>
+              <a:r>
+                <a:rPr lang="en-US" dirty="0">
+                  <a:latin typeface="Helvetica" pitchFamily="2" charset="0"/>
+                  <a:cs typeface="Arial" panose="020B0604020202020204" pitchFamily="34" charset="0"/>
+                </a:rPr>
+                <a:t>c) Fitted sparse model</a:t>
+              </a:r>
+            </a:p>
+          </p:txBody>
+        </p:sp>
       </p:grpSp>
     </p:spTree>
     <p:extLst>

</xml_diff>

<commit_message>
Hopefully final updates before initial submittion to Ecol Monographs
</commit_message>
<xml_diff>
--- a/Figures/concept_fig_editable.pptx
+++ b/Figures/concept_fig_editable.pptx
@@ -297,7 +297,7 @@
           <a:p>
             <a:fld id="{E6744CE3-0875-4B69-89C0-6F72D8139561}" type="datetimeFigureOut">
               <a:rPr lang="en-GB" smtClean="0"/>
-              <a:t>26/07/2024</a:t>
+              <a:t>06/09/2024</a:t>
             </a:fld>
             <a:endParaRPr lang="en-GB"/>
           </a:p>
@@ -467,7 +467,7 @@
           <a:p>
             <a:fld id="{E6744CE3-0875-4B69-89C0-6F72D8139561}" type="datetimeFigureOut">
               <a:rPr lang="en-GB" smtClean="0"/>
-              <a:t>26/07/2024</a:t>
+              <a:t>06/09/2024</a:t>
             </a:fld>
             <a:endParaRPr lang="en-GB"/>
           </a:p>
@@ -713,7 +713,7 @@
           <a:p>
             <a:fld id="{E6744CE3-0875-4B69-89C0-6F72D8139561}" type="datetimeFigureOut">
               <a:rPr lang="en-GB" smtClean="0"/>
-              <a:t>26/07/2024</a:t>
+              <a:t>06/09/2024</a:t>
             </a:fld>
             <a:endParaRPr lang="en-GB"/>
           </a:p>
@@ -1001,7 +1001,7 @@
           <a:p>
             <a:fld id="{E6744CE3-0875-4B69-89C0-6F72D8139561}" type="datetimeFigureOut">
               <a:rPr lang="en-GB" smtClean="0"/>
-              <a:t>26/07/2024</a:t>
+              <a:t>06/09/2024</a:t>
             </a:fld>
             <a:endParaRPr lang="en-GB"/>
           </a:p>
@@ -1423,7 +1423,7 @@
           <a:p>
             <a:fld id="{E6744CE3-0875-4B69-89C0-6F72D8139561}" type="datetimeFigureOut">
               <a:rPr lang="en-GB" smtClean="0"/>
-              <a:t>26/07/2024</a:t>
+              <a:t>06/09/2024</a:t>
             </a:fld>
             <a:endParaRPr lang="en-GB"/>
           </a:p>
@@ -1541,7 +1541,7 @@
           <a:p>
             <a:fld id="{E6744CE3-0875-4B69-89C0-6F72D8139561}" type="datetimeFigureOut">
               <a:rPr lang="en-GB" smtClean="0"/>
-              <a:t>26/07/2024</a:t>
+              <a:t>06/09/2024</a:t>
             </a:fld>
             <a:endParaRPr lang="en-GB"/>
           </a:p>
@@ -1636,7 +1636,7 @@
           <a:p>
             <a:fld id="{E6744CE3-0875-4B69-89C0-6F72D8139561}" type="datetimeFigureOut">
               <a:rPr lang="en-GB" smtClean="0"/>
-              <a:t>26/07/2024</a:t>
+              <a:t>06/09/2024</a:t>
             </a:fld>
             <a:endParaRPr lang="en-GB"/>
           </a:p>
@@ -1849,7 +1849,7 @@
           <a:p>
             <a:fld id="{E6744CE3-0875-4B69-89C0-6F72D8139561}" type="datetimeFigureOut">
               <a:rPr lang="en-GB" smtClean="0"/>
-              <a:t>26/07/2024</a:t>
+              <a:t>06/09/2024</a:t>
             </a:fld>
             <a:endParaRPr lang="en-GB"/>
           </a:p>
@@ -2882,10 +2882,10 @@
       </p:grpSpPr>
       <p:grpSp>
         <p:nvGrpSpPr>
-          <p:cNvPr id="8" name="Group 7">
+          <p:cNvPr id="20" name="Group 19">
             <a:extLst>
               <a:ext uri="{FF2B5EF4-FFF2-40B4-BE49-F238E27FC236}">
-                <a16:creationId xmlns:a16="http://schemas.microsoft.com/office/drawing/2014/main" id="{33EB0A24-0980-C22E-4F90-123436975B96}"/>
+                <a16:creationId xmlns:a16="http://schemas.microsoft.com/office/drawing/2014/main" id="{C406C71B-D3D8-4220-8916-7ED2F9B8F1BE}"/>
               </a:ext>
             </a:extLst>
           </p:cNvPr>
@@ -2894,9 +2894,9 @@
         </p:nvGrpSpPr>
         <p:grpSpPr>
           <a:xfrm>
-            <a:off x="505983" y="260648"/>
+            <a:off x="539552" y="260648"/>
             <a:ext cx="8242481" cy="6336704"/>
-            <a:chOff x="505983" y="260648"/>
+            <a:chOff x="539552" y="260648"/>
             <a:chExt cx="8242481" cy="6336704"/>
           </a:xfrm>
         </p:grpSpPr>
@@ -2914,7 +2914,7 @@
           </p:nvSpPr>
           <p:spPr>
             <a:xfrm>
-              <a:off x="544123" y="260648"/>
+              <a:off x="577692" y="260648"/>
               <a:ext cx="8204341" cy="6336704"/>
             </a:xfrm>
             <a:prstGeom prst="rect">
@@ -2950,7 +2950,7 @@
             <a:lstStyle/>
             <a:p>
               <a:pPr algn="ctr"/>
-              <a:endParaRPr lang="en-US"/>
+              <a:endParaRPr lang="en-US" dirty="0"/>
             </a:p>
           </p:txBody>
         </p:sp>
@@ -2982,43 +2982,8 @@
           </p:blipFill>
           <p:spPr>
             <a:xfrm>
-              <a:off x="635413" y="701988"/>
+              <a:off x="668982" y="701988"/>
               <a:ext cx="2743200" cy="1371600"/>
-            </a:xfrm>
-            <a:prstGeom prst="rect">
-              <a:avLst/>
-            </a:prstGeom>
-          </p:spPr>
-        </p:pic>
-        <p:pic>
-          <p:nvPicPr>
-            <p:cNvPr id="34" name="Picture 33" descr="A set of colorful lines&#10;&#10;Description automatically generated with medium confidence">
-              <a:extLst>
-                <a:ext uri="{FF2B5EF4-FFF2-40B4-BE49-F238E27FC236}">
-                  <a16:creationId xmlns:a16="http://schemas.microsoft.com/office/drawing/2014/main" id="{E3DC1B72-B027-064F-402F-EE663B6FD6BC}"/>
-                </a:ext>
-              </a:extLst>
-            </p:cNvPr>
-            <p:cNvPicPr>
-              <a:picLocks/>
-            </p:cNvPicPr>
-            <p:nvPr/>
-          </p:nvPicPr>
-          <p:blipFill rotWithShape="1">
-            <a:blip r:embed="rId3">
-              <a:extLst>
-                <a:ext uri="{28A0092B-C50C-407E-A947-70E740481C1C}">
-                  <a14:useLocalDpi xmlns:a14="http://schemas.microsoft.com/office/drawing/2010/main" val="0"/>
-                </a:ext>
-              </a:extLst>
-            </a:blip>
-            <a:srcRect b="35117"/>
-            <a:stretch/>
-          </p:blipFill>
-          <p:spPr>
-            <a:xfrm>
-              <a:off x="505983" y="2073588"/>
-              <a:ext cx="3002059" cy="2660848"/>
             </a:xfrm>
             <a:prstGeom prst="rect">
               <a:avLst/>
@@ -3052,7 +3017,7 @@
           </p:blipFill>
           <p:spPr>
             <a:xfrm>
-              <a:off x="505983" y="4878452"/>
+              <a:off x="539552" y="4878452"/>
               <a:ext cx="3002059" cy="648072"/>
             </a:xfrm>
             <a:prstGeom prst="rect">
@@ -3074,7 +3039,7 @@
           </p:nvSpPr>
           <p:spPr>
             <a:xfrm rot="5400000">
-              <a:off x="1966690" y="4606389"/>
+              <a:off x="2000259" y="4606389"/>
               <a:ext cx="432048" cy="400110"/>
             </a:xfrm>
             <a:prstGeom prst="rect">
@@ -3122,7 +3087,7 @@
           </p:blipFill>
           <p:spPr>
             <a:xfrm>
-              <a:off x="505983" y="5670540"/>
+              <a:off x="539552" y="5670540"/>
               <a:ext cx="3002059" cy="792088"/>
             </a:xfrm>
             <a:prstGeom prst="rect">
@@ -3144,7 +3109,7 @@
           </p:nvSpPr>
           <p:spPr>
             <a:xfrm rot="5400000">
-              <a:off x="1966690" y="5398477"/>
+              <a:off x="2000259" y="5398477"/>
               <a:ext cx="432048" cy="400110"/>
             </a:xfrm>
             <a:prstGeom prst="rect">
@@ -3165,12 +3130,127 @@
             </a:p>
           </p:txBody>
         </p:sp>
+        <p:sp>
+          <p:nvSpPr>
+            <p:cNvPr id="97" name="TextBox 96">
+              <a:extLst>
+                <a:ext uri="{FF2B5EF4-FFF2-40B4-BE49-F238E27FC236}">
+                  <a16:creationId xmlns:a16="http://schemas.microsoft.com/office/drawing/2014/main" id="{9543B056-7D7B-0389-6F20-CF9C830C2F6D}"/>
+                </a:ext>
+              </a:extLst>
+            </p:cNvPr>
+            <p:cNvSpPr txBox="1"/>
+            <p:nvPr/>
+          </p:nvSpPr>
+          <p:spPr>
+            <a:xfrm>
+              <a:off x="577693" y="260648"/>
+              <a:ext cx="1980029" cy="369332"/>
+            </a:xfrm>
+            <a:prstGeom prst="rect">
+              <a:avLst/>
+            </a:prstGeom>
+            <a:noFill/>
+          </p:spPr>
+          <p:txBody>
+            <a:bodyPr wrap="square" rtlCol="0">
+              <a:spAutoFit/>
+            </a:bodyPr>
+            <a:lstStyle/>
+            <a:p>
+              <a:r>
+                <a:rPr lang="en-US" dirty="0">
+                  <a:latin typeface="Helvetica" pitchFamily="2" charset="0"/>
+                  <a:cs typeface="Arial" panose="020B0604020202020204" pitchFamily="34" charset="0"/>
+                </a:rPr>
+                <a:t>a) Decomposition</a:t>
+              </a:r>
+            </a:p>
+          </p:txBody>
+        </p:sp>
+        <p:sp>
+          <p:nvSpPr>
+            <p:cNvPr id="99" name="TextBox 98">
+              <a:extLst>
+                <a:ext uri="{FF2B5EF4-FFF2-40B4-BE49-F238E27FC236}">
+                  <a16:creationId xmlns:a16="http://schemas.microsoft.com/office/drawing/2014/main" id="{48CF7F87-F487-0602-8884-FE9FE6E3A1BD}"/>
+                </a:ext>
+              </a:extLst>
+            </p:cNvPr>
+            <p:cNvSpPr txBox="1"/>
+            <p:nvPr/>
+          </p:nvSpPr>
+          <p:spPr>
+            <a:xfrm>
+              <a:off x="3636757" y="260648"/>
+              <a:ext cx="3463128" cy="369332"/>
+            </a:xfrm>
+            <a:prstGeom prst="rect">
+              <a:avLst/>
+            </a:prstGeom>
+            <a:noFill/>
+          </p:spPr>
+          <p:txBody>
+            <a:bodyPr wrap="square" rtlCol="0">
+              <a:spAutoFit/>
+            </a:bodyPr>
+            <a:lstStyle/>
+            <a:p>
+              <a:pPr marL="7938"/>
+              <a:r>
+                <a:rPr lang="en-US" dirty="0">
+                  <a:latin typeface="Helvetica" pitchFamily="2" charset="0"/>
+                  <a:cs typeface="Arial" panose="020B0604020202020204" pitchFamily="34" charset="0"/>
+                </a:rPr>
+                <a:t>b) Possible linear combinations</a:t>
+              </a:r>
+            </a:p>
+          </p:txBody>
+        </p:sp>
+        <p:sp>
+          <p:nvSpPr>
+            <p:cNvPr id="7" name="TextBox 6">
+              <a:extLst>
+                <a:ext uri="{FF2B5EF4-FFF2-40B4-BE49-F238E27FC236}">
+                  <a16:creationId xmlns:a16="http://schemas.microsoft.com/office/drawing/2014/main" id="{982298F3-2624-FF75-8CDA-577D01C92BE0}"/>
+                </a:ext>
+              </a:extLst>
+            </p:cNvPr>
+            <p:cNvSpPr txBox="1"/>
+            <p:nvPr/>
+          </p:nvSpPr>
+          <p:spPr>
+            <a:xfrm>
+              <a:off x="3655144" y="3501008"/>
+              <a:ext cx="2467342" cy="369332"/>
+            </a:xfrm>
+            <a:prstGeom prst="rect">
+              <a:avLst/>
+            </a:prstGeom>
+            <a:noFill/>
+          </p:spPr>
+          <p:txBody>
+            <a:bodyPr wrap="square" rtlCol="0">
+              <a:spAutoFit/>
+            </a:bodyPr>
+            <a:lstStyle/>
+            <a:p>
+              <a:r>
+                <a:rPr lang="en-US" dirty="0">
+                  <a:latin typeface="Helvetica" pitchFamily="2" charset="0"/>
+                  <a:cs typeface="Arial" panose="020B0604020202020204" pitchFamily="34" charset="0"/>
+                </a:rPr>
+                <a:t>c) Fitted sparse model</a:t>
+              </a:r>
+            </a:p>
+          </p:txBody>
+        </p:sp>
         <p:grpSp>
           <p:nvGrpSpPr>
-            <p:cNvPr id="4" name="Group 3">
+            <p:cNvPr id="10" name="Group 9">
               <a:extLst>
                 <a:ext uri="{FF2B5EF4-FFF2-40B4-BE49-F238E27FC236}">
-                  <a16:creationId xmlns:a16="http://schemas.microsoft.com/office/drawing/2014/main" id="{B3A20E04-6E01-7B6D-E250-7815802ACCF8}"/>
+                  <a16:creationId xmlns:a16="http://schemas.microsoft.com/office/drawing/2014/main" id="{B5D4191C-F89F-9959-F778-925DA0093068}"/>
                 </a:ext>
               </a:extLst>
             </p:cNvPr>
@@ -3179,592 +3259,23 @@
           </p:nvGrpSpPr>
           <p:grpSpPr>
             <a:xfrm>
-              <a:off x="3538395" y="751065"/>
-              <a:ext cx="5091830" cy="1371600"/>
-              <a:chOff x="3544253" y="2875920"/>
-              <a:chExt cx="5091830" cy="1371600"/>
+              <a:off x="539552" y="2055746"/>
+              <a:ext cx="3002059" cy="4253574"/>
+              <a:chOff x="539552" y="2055746"/>
+              <a:chExt cx="3002059" cy="4253574"/>
             </a:xfrm>
           </p:grpSpPr>
           <p:pic>
             <p:nvPicPr>
-              <p:cNvPr id="61" name="Picture 60" descr="A graph showing a line and time&#10;&#10;Description automatically generated with medium confidence">
+              <p:cNvPr id="34" name="Picture 33" descr="A set of colorful lines&#10;&#10;Description automatically generated with medium confidence">
                 <a:extLst>
                   <a:ext uri="{FF2B5EF4-FFF2-40B4-BE49-F238E27FC236}">
-                    <a16:creationId xmlns:a16="http://schemas.microsoft.com/office/drawing/2014/main" id="{866762CA-586C-B34C-AB73-9E48EC542420}"/>
+                    <a16:creationId xmlns:a16="http://schemas.microsoft.com/office/drawing/2014/main" id="{E3DC1B72-B027-064F-402F-EE663B6FD6BC}"/>
                   </a:ext>
                 </a:extLst>
               </p:cNvPr>
               <p:cNvPicPr>
-                <a:picLocks noChangeAspect="1"/>
-              </p:cNvPicPr>
-              <p:nvPr/>
-            </p:nvPicPr>
-            <p:blipFill>
-              <a:blip r:embed="rId4">
-                <a:extLst>
-                  <a:ext uri="{28A0092B-C50C-407E-A947-70E740481C1C}">
-                    <a14:useLocalDpi xmlns:a14="http://schemas.microsoft.com/office/drawing/2010/main" val="0"/>
-                  </a:ext>
-                </a:extLst>
-              </a:blip>
-              <a:stretch>
-                <a:fillRect/>
-              </a:stretch>
-            </p:blipFill>
-            <p:spPr>
-              <a:xfrm>
-                <a:off x="5892883" y="2875920"/>
-                <a:ext cx="2743200" cy="1371600"/>
-              </a:xfrm>
-              <a:prstGeom prst="rect">
-                <a:avLst/>
-              </a:prstGeom>
-            </p:spPr>
-          </p:pic>
-          <p:grpSp>
-            <p:nvGrpSpPr>
-              <p:cNvPr id="55" name="Group 54">
-                <a:extLst>
-                  <a:ext uri="{FF2B5EF4-FFF2-40B4-BE49-F238E27FC236}">
-                    <a16:creationId xmlns:a16="http://schemas.microsoft.com/office/drawing/2014/main" id="{99DAD50E-7A2B-7192-B6B4-C42B40D55331}"/>
-                  </a:ext>
-                </a:extLst>
-              </p:cNvPr>
-              <p:cNvGrpSpPr/>
-              <p:nvPr/>
-            </p:nvGrpSpPr>
-            <p:grpSpPr>
-              <a:xfrm>
-                <a:off x="3544253" y="3067474"/>
-                <a:ext cx="2128513" cy="736774"/>
-                <a:chOff x="3064000" y="2379140"/>
-                <a:chExt cx="3007616" cy="736774"/>
-              </a:xfrm>
-            </p:grpSpPr>
-            <p:pic>
-              <p:nvPicPr>
-                <p:cNvPr id="53" name="Picture 52" descr="A set of colorful lines&#10;&#10;Description automatically generated with medium confidence">
-                  <a:extLst>
-                    <a:ext uri="{FF2B5EF4-FFF2-40B4-BE49-F238E27FC236}">
-                      <a16:creationId xmlns:a16="http://schemas.microsoft.com/office/drawing/2014/main" id="{4FC52D71-2FE1-0D61-3BC0-8B623942261F}"/>
-                    </a:ext>
-                  </a:extLst>
-                </p:cNvPr>
-                <p:cNvPicPr>
-                  <a:picLocks noChangeAspect="1"/>
-                </p:cNvPicPr>
-                <p:nvPr/>
-              </p:nvPicPr>
-              <p:blipFill rotWithShape="1">
-                <a:blip r:embed="rId3">
-                  <a:extLst>
-                    <a:ext uri="{28A0092B-C50C-407E-A947-70E740481C1C}">
-                      <a14:useLocalDpi xmlns:a14="http://schemas.microsoft.com/office/drawing/2010/main" val="0"/>
-                    </a:ext>
-                  </a:extLst>
-                </a:blip>
-                <a:srcRect t="6859" b="84446"/>
-                <a:stretch/>
-              </p:blipFill>
-              <p:spPr>
-                <a:xfrm>
-                  <a:off x="3072384" y="2379140"/>
-                  <a:ext cx="2999232" cy="356592"/>
-                </a:xfrm>
-                <a:prstGeom prst="rect">
-                  <a:avLst/>
-                </a:prstGeom>
-              </p:spPr>
-            </p:pic>
-            <p:pic>
-              <p:nvPicPr>
-                <p:cNvPr id="54" name="Picture 53" descr="A set of colorful lines&#10;&#10;Description automatically generated with medium confidence">
-                  <a:extLst>
-                    <a:ext uri="{FF2B5EF4-FFF2-40B4-BE49-F238E27FC236}">
-                      <a16:creationId xmlns:a16="http://schemas.microsoft.com/office/drawing/2014/main" id="{908DEEE1-9B1C-EFCC-4B5F-FC7900478E6E}"/>
-                    </a:ext>
-                  </a:extLst>
-                </p:cNvPr>
-                <p:cNvPicPr>
-                  <a:picLocks noChangeAspect="1"/>
-                </p:cNvPicPr>
-                <p:nvPr/>
-              </p:nvPicPr>
-              <p:blipFill rotWithShape="1">
-                <a:blip r:embed="rId3">
-                  <a:extLst>
-                    <a:ext uri="{28A0092B-C50C-407E-A947-70E740481C1C}">
-                      <a14:useLocalDpi xmlns:a14="http://schemas.microsoft.com/office/drawing/2010/main" val="0"/>
-                    </a:ext>
-                  </a:extLst>
-                </a:blip>
-                <a:srcRect t="15356" b="75949"/>
-                <a:stretch/>
-              </p:blipFill>
-              <p:spPr>
-                <a:xfrm>
-                  <a:off x="3064000" y="2759322"/>
-                  <a:ext cx="2999232" cy="356592"/>
-                </a:xfrm>
-                <a:prstGeom prst="rect">
-                  <a:avLst/>
-                </a:prstGeom>
-              </p:spPr>
-            </p:pic>
-          </p:grpSp>
-          <p:sp>
-            <p:nvSpPr>
-              <p:cNvPr id="87" name="Right Arrow 86">
-                <a:extLst>
-                  <a:ext uri="{FF2B5EF4-FFF2-40B4-BE49-F238E27FC236}">
-                    <a16:creationId xmlns:a16="http://schemas.microsoft.com/office/drawing/2014/main" id="{FCA32D21-A010-E8A2-1053-513A97B98695}"/>
-                  </a:ext>
-                </a:extLst>
-              </p:cNvPr>
-              <p:cNvSpPr/>
-              <p:nvPr/>
-            </p:nvSpPr>
-            <p:spPr>
-              <a:xfrm>
-                <a:off x="5653591" y="3158902"/>
-                <a:ext cx="232268" cy="173736"/>
-              </a:xfrm>
-              <a:prstGeom prst="rightArrow">
-                <a:avLst/>
-              </a:prstGeom>
-              <a:solidFill>
-                <a:srgbClr val="00496F"/>
-              </a:solidFill>
-              <a:ln w="3175">
-                <a:solidFill>
-                  <a:schemeClr val="tx1"/>
-                </a:solidFill>
-              </a:ln>
-            </p:spPr>
-            <p:style>
-              <a:lnRef idx="2">
-                <a:schemeClr val="accent1">
-                  <a:shade val="15000"/>
-                </a:schemeClr>
-              </a:lnRef>
-              <a:fillRef idx="1">
-                <a:schemeClr val="accent1"/>
-              </a:fillRef>
-              <a:effectRef idx="0">
-                <a:schemeClr val="accent1"/>
-              </a:effectRef>
-              <a:fontRef idx="minor">
-                <a:schemeClr val="lt1"/>
-              </a:fontRef>
-            </p:style>
-            <p:txBody>
-              <a:bodyPr rtlCol="0" anchor="ctr"/>
-              <a:lstStyle/>
-              <a:p>
-                <a:pPr algn="ctr"/>
-                <a:endParaRPr lang="en-US"/>
-              </a:p>
-            </p:txBody>
-          </p:sp>
-          <p:sp>
-            <p:nvSpPr>
-              <p:cNvPr id="88" name="Right Arrow 87">
-                <a:extLst>
-                  <a:ext uri="{FF2B5EF4-FFF2-40B4-BE49-F238E27FC236}">
-                    <a16:creationId xmlns:a16="http://schemas.microsoft.com/office/drawing/2014/main" id="{8824C285-2611-8FF9-70B2-10C200B339F9}"/>
-                  </a:ext>
-                </a:extLst>
-              </p:cNvPr>
-              <p:cNvSpPr/>
-              <p:nvPr/>
-            </p:nvSpPr>
-            <p:spPr>
-              <a:xfrm>
-                <a:off x="5647030" y="3603821"/>
-                <a:ext cx="232268" cy="73152"/>
-              </a:xfrm>
-              <a:prstGeom prst="rightArrow">
-                <a:avLst/>
-              </a:prstGeom>
-              <a:solidFill>
-                <a:srgbClr val="0C7996"/>
-              </a:solidFill>
-              <a:ln w="3175">
-                <a:solidFill>
-                  <a:schemeClr val="tx1"/>
-                </a:solidFill>
-              </a:ln>
-            </p:spPr>
-            <p:style>
-              <a:lnRef idx="2">
-                <a:schemeClr val="accent1">
-                  <a:shade val="15000"/>
-                </a:schemeClr>
-              </a:lnRef>
-              <a:fillRef idx="1">
-                <a:schemeClr val="accent1"/>
-              </a:fillRef>
-              <a:effectRef idx="0">
-                <a:schemeClr val="accent1"/>
-              </a:effectRef>
-              <a:fontRef idx="minor">
-                <a:schemeClr val="lt1"/>
-              </a:fontRef>
-            </p:style>
-            <p:txBody>
-              <a:bodyPr rtlCol="0" anchor="ctr"/>
-              <a:lstStyle/>
-              <a:p>
-                <a:pPr algn="ctr"/>
-                <a:endParaRPr lang="en-US"/>
-              </a:p>
-            </p:txBody>
-          </p:sp>
-        </p:grpSp>
-        <p:grpSp>
-          <p:nvGrpSpPr>
-            <p:cNvPr id="3" name="Group 2">
-              <a:extLst>
-                <a:ext uri="{FF2B5EF4-FFF2-40B4-BE49-F238E27FC236}">
-                  <a16:creationId xmlns:a16="http://schemas.microsoft.com/office/drawing/2014/main" id="{CF54F3C6-E541-849F-0EDB-886867563FF0}"/>
-                </a:ext>
-              </a:extLst>
-            </p:cNvPr>
-            <p:cNvGrpSpPr/>
-            <p:nvPr/>
-          </p:nvGrpSpPr>
-          <p:grpSpPr>
-            <a:xfrm>
-              <a:off x="3531914" y="2055746"/>
-              <a:ext cx="5093985" cy="1371600"/>
-              <a:chOff x="3537058" y="1206044"/>
-              <a:chExt cx="5093985" cy="1371600"/>
-            </a:xfrm>
-          </p:grpSpPr>
-          <p:pic>
-            <p:nvPicPr>
-              <p:cNvPr id="59" name="Picture 58" descr="A graph showing a line&#10;&#10;Description automatically generated with medium confidence">
-                <a:extLst>
-                  <a:ext uri="{FF2B5EF4-FFF2-40B4-BE49-F238E27FC236}">
-                    <a16:creationId xmlns:a16="http://schemas.microsoft.com/office/drawing/2014/main" id="{4F18A0D3-4D6F-7AF3-BAEA-0FF0E2C4E3A0}"/>
-                  </a:ext>
-                </a:extLst>
-              </p:cNvPr>
-              <p:cNvPicPr>
-                <a:picLocks noChangeAspect="1"/>
-              </p:cNvPicPr>
-              <p:nvPr/>
-            </p:nvPicPr>
-            <p:blipFill>
-              <a:blip r:embed="rId5">
-                <a:extLst>
-                  <a:ext uri="{28A0092B-C50C-407E-A947-70E740481C1C}">
-                    <a14:useLocalDpi xmlns:a14="http://schemas.microsoft.com/office/drawing/2010/main" val="0"/>
-                  </a:ext>
-                </a:extLst>
-              </a:blip>
-              <a:stretch>
-                <a:fillRect/>
-              </a:stretch>
-            </p:blipFill>
-            <p:spPr>
-              <a:xfrm>
-                <a:off x="5887843" y="1206044"/>
-                <a:ext cx="2743200" cy="1371600"/>
-              </a:xfrm>
-              <a:prstGeom prst="rect">
-                <a:avLst/>
-              </a:prstGeom>
-            </p:spPr>
-          </p:pic>
-          <p:grpSp>
-            <p:nvGrpSpPr>
-              <p:cNvPr id="2" name="Group 1">
-                <a:extLst>
-                  <a:ext uri="{FF2B5EF4-FFF2-40B4-BE49-F238E27FC236}">
-                    <a16:creationId xmlns:a16="http://schemas.microsoft.com/office/drawing/2014/main" id="{ED3E23CA-2CEE-E1D1-31C2-DEBC3F9BAB37}"/>
-                  </a:ext>
-                </a:extLst>
-              </p:cNvPr>
-              <p:cNvGrpSpPr/>
-              <p:nvPr/>
-            </p:nvGrpSpPr>
-            <p:grpSpPr>
-              <a:xfrm>
-                <a:off x="3537058" y="1437204"/>
-                <a:ext cx="2348844" cy="713184"/>
-                <a:chOff x="3537058" y="1437204"/>
-                <a:chExt cx="2348844" cy="713184"/>
-              </a:xfrm>
-            </p:grpSpPr>
-            <p:grpSp>
-              <p:nvGrpSpPr>
-                <p:cNvPr id="52" name="Group 51">
-                  <a:extLst>
-                    <a:ext uri="{FF2B5EF4-FFF2-40B4-BE49-F238E27FC236}">
-                      <a16:creationId xmlns:a16="http://schemas.microsoft.com/office/drawing/2014/main" id="{20374367-B742-193E-1A0B-914729C24DA8}"/>
-                    </a:ext>
-                  </a:extLst>
-                </p:cNvPr>
-                <p:cNvGrpSpPr/>
-                <p:nvPr/>
-              </p:nvGrpSpPr>
-              <p:grpSpPr>
-                <a:xfrm>
-                  <a:off x="3537058" y="1437204"/>
-                  <a:ext cx="2128512" cy="713184"/>
-                  <a:chOff x="3174888" y="1268760"/>
-                  <a:chExt cx="2999232" cy="713184"/>
-                </a:xfrm>
-              </p:grpSpPr>
-              <p:pic>
-                <p:nvPicPr>
-                  <p:cNvPr id="48" name="Picture 47" descr="A set of colorful lines&#10;&#10;Description automatically generated with medium confidence">
-                    <a:extLst>
-                      <a:ext uri="{FF2B5EF4-FFF2-40B4-BE49-F238E27FC236}">
-                        <a16:creationId xmlns:a16="http://schemas.microsoft.com/office/drawing/2014/main" id="{0A5EFB53-9B99-460E-4837-3F4E961E8928}"/>
-                      </a:ext>
-                    </a:extLst>
-                  </p:cNvPr>
-                  <p:cNvPicPr>
-                    <a:picLocks noChangeAspect="1"/>
-                  </p:cNvPicPr>
-                  <p:nvPr/>
-                </p:nvPicPr>
-                <p:blipFill rotWithShape="1">
-                  <a:blip r:embed="rId3">
-                    <a:extLst>
-                      <a:ext uri="{28A0092B-C50C-407E-A947-70E740481C1C}">
-                        <a14:useLocalDpi xmlns:a14="http://schemas.microsoft.com/office/drawing/2010/main" val="0"/>
-                      </a:ext>
-                    </a:extLst>
-                  </a:blip>
-                  <a:srcRect b="91305"/>
-                  <a:stretch/>
-                </p:blipFill>
-                <p:spPr>
-                  <a:xfrm>
-                    <a:off x="3174888" y="1268760"/>
-                    <a:ext cx="2999232" cy="356592"/>
-                  </a:xfrm>
-                  <a:prstGeom prst="rect">
-                    <a:avLst/>
-                  </a:prstGeom>
-                </p:spPr>
-              </p:pic>
-              <p:pic>
-                <p:nvPicPr>
-                  <p:cNvPr id="51" name="Picture 50" descr="A set of colorful lines&#10;&#10;Description automatically generated with medium confidence">
-                    <a:extLst>
-                      <a:ext uri="{FF2B5EF4-FFF2-40B4-BE49-F238E27FC236}">
-                        <a16:creationId xmlns:a16="http://schemas.microsoft.com/office/drawing/2014/main" id="{6D3A3A9D-0122-82E9-B566-44C8A7AB2728}"/>
-                      </a:ext>
-                    </a:extLst>
-                  </p:cNvPr>
-                  <p:cNvPicPr>
-                    <a:picLocks noChangeAspect="1"/>
-                  </p:cNvPicPr>
-                  <p:nvPr/>
-                </p:nvPicPr>
-                <p:blipFill rotWithShape="1">
-                  <a:blip r:embed="rId3">
-                    <a:extLst>
-                      <a:ext uri="{28A0092B-C50C-407E-A947-70E740481C1C}">
-                        <a14:useLocalDpi xmlns:a14="http://schemas.microsoft.com/office/drawing/2010/main" val="0"/>
-                      </a:ext>
-                    </a:extLst>
-                  </a:blip>
-                  <a:srcRect t="64340" b="26965"/>
-                  <a:stretch/>
-                </p:blipFill>
-                <p:spPr>
-                  <a:xfrm>
-                    <a:off x="3174888" y="1625352"/>
-                    <a:ext cx="2999232" cy="356592"/>
-                  </a:xfrm>
-                  <a:prstGeom prst="rect">
-                    <a:avLst/>
-                  </a:prstGeom>
-                </p:spPr>
-              </p:pic>
-            </p:grpSp>
-            <p:sp>
-              <p:nvSpPr>
-                <p:cNvPr id="85" name="Right Arrow 84">
-                  <a:extLst>
-                    <a:ext uri="{FF2B5EF4-FFF2-40B4-BE49-F238E27FC236}">
-                      <a16:creationId xmlns:a16="http://schemas.microsoft.com/office/drawing/2014/main" id="{7DFE395F-4AF2-0B3D-3B33-EBBB8DFB2039}"/>
-                    </a:ext>
-                  </a:extLst>
-                </p:cNvPr>
-                <p:cNvSpPr/>
-                <p:nvPr/>
-              </p:nvSpPr>
-              <p:spPr>
-                <a:xfrm>
-                  <a:off x="5653634" y="1438751"/>
-                  <a:ext cx="232268" cy="274320"/>
-                </a:xfrm>
-                <a:prstGeom prst="rightArrow">
-                  <a:avLst/>
-                </a:prstGeom>
-                <a:solidFill>
-                  <a:srgbClr val="00496F"/>
-                </a:solidFill>
-                <a:ln w="3175">
-                  <a:solidFill>
-                    <a:schemeClr val="tx1"/>
-                  </a:solidFill>
-                </a:ln>
-              </p:spPr>
-              <p:style>
-                <a:lnRef idx="2">
-                  <a:schemeClr val="accent1">
-                    <a:shade val="15000"/>
-                  </a:schemeClr>
-                </a:lnRef>
-                <a:fillRef idx="1">
-                  <a:schemeClr val="accent1"/>
-                </a:fillRef>
-                <a:effectRef idx="0">
-                  <a:schemeClr val="accent1"/>
-                </a:effectRef>
-                <a:fontRef idx="minor">
-                  <a:schemeClr val="lt1"/>
-                </a:fontRef>
-              </p:style>
-              <p:txBody>
-                <a:bodyPr rtlCol="0" anchor="ctr"/>
-                <a:lstStyle/>
-                <a:p>
-                  <a:pPr algn="ctr"/>
-                  <a:endParaRPr lang="en-US"/>
-                </a:p>
-              </p:txBody>
-            </p:sp>
-            <p:sp>
-              <p:nvSpPr>
-                <p:cNvPr id="86" name="Right Arrow 85">
-                  <a:extLst>
-                    <a:ext uri="{FF2B5EF4-FFF2-40B4-BE49-F238E27FC236}">
-                      <a16:creationId xmlns:a16="http://schemas.microsoft.com/office/drawing/2014/main" id="{70AEB2B5-4C1B-6AA9-EF9F-4B69ADFDDC0B}"/>
-                    </a:ext>
-                  </a:extLst>
-                </p:cNvPr>
-                <p:cNvSpPr/>
-                <p:nvPr/>
-              </p:nvSpPr>
-              <p:spPr>
-                <a:xfrm>
-                  <a:off x="5653634" y="1853237"/>
-                  <a:ext cx="232268" cy="173736"/>
-                </a:xfrm>
-                <a:prstGeom prst="rightArrow">
-                  <a:avLst/>
-                </a:prstGeom>
-                <a:solidFill>
-                  <a:srgbClr val="E97C07"/>
-                </a:solidFill>
-                <a:ln w="3175">
-                  <a:solidFill>
-                    <a:schemeClr val="tx1"/>
-                  </a:solidFill>
-                </a:ln>
-              </p:spPr>
-              <p:style>
-                <a:lnRef idx="2">
-                  <a:schemeClr val="accent1">
-                    <a:shade val="15000"/>
-                  </a:schemeClr>
-                </a:lnRef>
-                <a:fillRef idx="1">
-                  <a:schemeClr val="accent1"/>
-                </a:fillRef>
-                <a:effectRef idx="0">
-                  <a:schemeClr val="accent1"/>
-                </a:effectRef>
-                <a:fontRef idx="minor">
-                  <a:schemeClr val="lt1"/>
-                </a:fontRef>
-              </p:style>
-              <p:txBody>
-                <a:bodyPr rtlCol="0" anchor="ctr"/>
-                <a:lstStyle/>
-                <a:p>
-                  <a:pPr algn="ctr"/>
-                  <a:endParaRPr lang="en-US"/>
-                </a:p>
-              </p:txBody>
-            </p:sp>
-          </p:grpSp>
-        </p:grpSp>
-        <p:grpSp>
-          <p:nvGrpSpPr>
-            <p:cNvPr id="6" name="Group 5">
-              <a:extLst>
-                <a:ext uri="{FF2B5EF4-FFF2-40B4-BE49-F238E27FC236}">
-                  <a16:creationId xmlns:a16="http://schemas.microsoft.com/office/drawing/2014/main" id="{F91089BB-49C6-D7C8-678F-2F144AD6AD6C}"/>
-                </a:ext>
-              </a:extLst>
-            </p:cNvPr>
-            <p:cNvGrpSpPr/>
-            <p:nvPr/>
-          </p:nvGrpSpPr>
-          <p:grpSpPr>
-            <a:xfrm>
-              <a:off x="3531914" y="4522727"/>
-              <a:ext cx="5106102" cy="1498561"/>
-              <a:chOff x="3531914" y="4418835"/>
-              <a:chExt cx="5106102" cy="1498561"/>
-            </a:xfrm>
-          </p:grpSpPr>
-          <p:pic>
-            <p:nvPicPr>
-              <p:cNvPr id="63" name="Picture 62" descr="A graph showing a line of time&#10;&#10;Description automatically generated">
-                <a:extLst>
-                  <a:ext uri="{FF2B5EF4-FFF2-40B4-BE49-F238E27FC236}">
-                    <a16:creationId xmlns:a16="http://schemas.microsoft.com/office/drawing/2014/main" id="{4670FD12-50CE-503B-BAA7-F976D5EA3117}"/>
-                  </a:ext>
-                </a:extLst>
-              </p:cNvPr>
-              <p:cNvPicPr>
-                <a:picLocks noChangeAspect="1"/>
-              </p:cNvPicPr>
-              <p:nvPr/>
-            </p:nvPicPr>
-            <p:blipFill>
-              <a:blip r:embed="rId6">
-                <a:extLst>
-                  <a:ext uri="{28A0092B-C50C-407E-A947-70E740481C1C}">
-                    <a14:useLocalDpi xmlns:a14="http://schemas.microsoft.com/office/drawing/2010/main" val="0"/>
-                  </a:ext>
-                </a:extLst>
-              </a:blip>
-              <a:stretch>
-                <a:fillRect/>
-              </a:stretch>
-            </p:blipFill>
-            <p:spPr>
-              <a:xfrm>
-                <a:off x="5894816" y="4545796"/>
-                <a:ext cx="2743200" cy="1371600"/>
-              </a:xfrm>
-              <a:prstGeom prst="rect">
-                <a:avLst/>
-              </a:prstGeom>
-            </p:spPr>
-          </p:pic>
-          <p:pic>
-            <p:nvPicPr>
-              <p:cNvPr id="56" name="Picture 55" descr="A set of colorful lines&#10;&#10;Description automatically generated with medium confidence">
-                <a:extLst>
-                  <a:ext uri="{FF2B5EF4-FFF2-40B4-BE49-F238E27FC236}">
-                    <a16:creationId xmlns:a16="http://schemas.microsoft.com/office/drawing/2014/main" id="{E25B4579-A89B-BBE3-0542-187D7C9A9117}"/>
-                  </a:ext>
-                </a:extLst>
-              </p:cNvPr>
-              <p:cNvPicPr>
-                <a:picLocks noChangeAspect="1"/>
+                <a:picLocks/>
               </p:cNvPicPr>
               <p:nvPr/>
             </p:nvPicPr>
@@ -3776,48 +3287,13 @@
                   </a:ext>
                 </a:extLst>
               </a:blip>
-              <a:srcRect b="83945"/>
+              <a:srcRect b="35117"/>
               <a:stretch/>
             </p:blipFill>
             <p:spPr>
               <a:xfrm>
-                <a:off x="3538395" y="4419767"/>
-                <a:ext cx="2122579" cy="658416"/>
-              </a:xfrm>
-              <a:prstGeom prst="rect">
-                <a:avLst/>
-              </a:prstGeom>
-            </p:spPr>
-          </p:pic>
-          <p:pic>
-            <p:nvPicPr>
-              <p:cNvPr id="57" name="Picture 56" descr="A set of colorful lines&#10;&#10;Description automatically generated with medium confidence">
-                <a:extLst>
-                  <a:ext uri="{FF2B5EF4-FFF2-40B4-BE49-F238E27FC236}">
-                    <a16:creationId xmlns:a16="http://schemas.microsoft.com/office/drawing/2014/main" id="{184A4771-D284-7615-3F6D-49AC45E1B0A4}"/>
-                  </a:ext>
-                </a:extLst>
-              </p:cNvPr>
-              <p:cNvPicPr>
-                <a:picLocks noChangeAspect="1"/>
-              </p:cNvPicPr>
-              <p:nvPr/>
-            </p:nvPicPr>
-            <p:blipFill rotWithShape="1">
-              <a:blip r:embed="rId3">
-                <a:extLst>
-                  <a:ext uri="{28A0092B-C50C-407E-A947-70E740481C1C}">
-                    <a14:useLocalDpi xmlns:a14="http://schemas.microsoft.com/office/drawing/2010/main" val="0"/>
-                  </a:ext>
-                </a:extLst>
-              </a:blip>
-              <a:srcRect t="49023" b="35968"/>
-              <a:stretch/>
-            </p:blipFill>
-            <p:spPr>
-              <a:xfrm>
-                <a:off x="3531914" y="5101516"/>
-                <a:ext cx="2122579" cy="615519"/>
+                <a:off x="539552" y="2073588"/>
+                <a:ext cx="3002059" cy="2660848"/>
               </a:xfrm>
               <a:prstGeom prst="rect">
                 <a:avLst/>
@@ -3826,10 +3302,10 @@
           </p:pic>
           <p:sp>
             <p:nvSpPr>
-              <p:cNvPr id="89" name="Right Arrow 88">
+              <p:cNvPr id="9" name="Rectangle 8">
                 <a:extLst>
                   <a:ext uri="{FF2B5EF4-FFF2-40B4-BE49-F238E27FC236}">
-                    <a16:creationId xmlns:a16="http://schemas.microsoft.com/office/drawing/2014/main" id="{234E50D9-1BAF-098C-89FC-B13225B68B2B}"/>
+                    <a16:creationId xmlns:a16="http://schemas.microsoft.com/office/drawing/2014/main" id="{5C9FED31-1278-D621-C31B-20BAB87F37C2}"/>
                   </a:ext>
                 </a:extLst>
               </p:cNvPr>
@@ -3838,181 +3314,17 @@
             </p:nvSpPr>
             <p:spPr>
               <a:xfrm>
-                <a:off x="5653591" y="4418835"/>
-                <a:ext cx="232268" cy="274320"/>
+                <a:off x="716671" y="2055746"/>
+                <a:ext cx="163448" cy="4253574"/>
               </a:xfrm>
-              <a:prstGeom prst="rightArrow">
+              <a:prstGeom prst="rect">
                 <a:avLst/>
               </a:prstGeom>
               <a:solidFill>
-                <a:srgbClr val="00496F"/>
+                <a:schemeClr val="bg1"/>
               </a:solidFill>
-              <a:ln w="3175">
-                <a:solidFill>
-                  <a:schemeClr val="tx1"/>
-                </a:solidFill>
-              </a:ln>
-            </p:spPr>
-            <p:style>
-              <a:lnRef idx="2">
-                <a:schemeClr val="accent1">
-                  <a:shade val="15000"/>
-                </a:schemeClr>
-              </a:lnRef>
-              <a:fillRef idx="1">
-                <a:schemeClr val="accent1"/>
-              </a:fillRef>
-              <a:effectRef idx="0">
-                <a:schemeClr val="accent1"/>
-              </a:effectRef>
-              <a:fontRef idx="minor">
-                <a:schemeClr val="lt1"/>
-              </a:fontRef>
-            </p:style>
-            <p:txBody>
-              <a:bodyPr rtlCol="0" anchor="ctr"/>
-              <a:lstStyle/>
-              <a:p>
-                <a:pPr algn="ctr"/>
-                <a:endParaRPr lang="en-US"/>
-              </a:p>
-            </p:txBody>
-          </p:sp>
-          <p:sp>
-            <p:nvSpPr>
-              <p:cNvPr id="91" name="Right Arrow 90">
-                <a:extLst>
-                  <a:ext uri="{FF2B5EF4-FFF2-40B4-BE49-F238E27FC236}">
-                    <a16:creationId xmlns:a16="http://schemas.microsoft.com/office/drawing/2014/main" id="{14E1EBDB-0F05-B4AC-8EDA-B7A3BAFAA3F8}"/>
-                  </a:ext>
-                </a:extLst>
-              </p:cNvPr>
-              <p:cNvSpPr/>
-              <p:nvPr/>
-            </p:nvSpPr>
-            <p:spPr>
-              <a:xfrm>
-                <a:off x="5647030" y="4853869"/>
-                <a:ext cx="232268" cy="73152"/>
-              </a:xfrm>
-              <a:prstGeom prst="rightArrow">
-                <a:avLst/>
-              </a:prstGeom>
-              <a:solidFill>
-                <a:srgbClr val="00496F"/>
-              </a:solidFill>
-              <a:ln w="3175">
-                <a:solidFill>
-                  <a:schemeClr val="tx1"/>
-                </a:solidFill>
-              </a:ln>
-            </p:spPr>
-            <p:style>
-              <a:lnRef idx="2">
-                <a:schemeClr val="accent1">
-                  <a:shade val="15000"/>
-                </a:schemeClr>
-              </a:lnRef>
-              <a:fillRef idx="1">
-                <a:schemeClr val="accent1"/>
-              </a:fillRef>
-              <a:effectRef idx="0">
-                <a:schemeClr val="accent1"/>
-              </a:effectRef>
-              <a:fontRef idx="minor">
-                <a:schemeClr val="lt1"/>
-              </a:fontRef>
-            </p:style>
-            <p:txBody>
-              <a:bodyPr rtlCol="0" anchor="ctr"/>
-              <a:lstStyle/>
-              <a:p>
-                <a:pPr algn="ctr"/>
-                <a:endParaRPr lang="en-US"/>
-              </a:p>
-            </p:txBody>
-          </p:sp>
-          <p:sp>
-            <p:nvSpPr>
-              <p:cNvPr id="92" name="Right Arrow 91">
-                <a:extLst>
-                  <a:ext uri="{FF2B5EF4-FFF2-40B4-BE49-F238E27FC236}">
-                    <a16:creationId xmlns:a16="http://schemas.microsoft.com/office/drawing/2014/main" id="{528F1F8F-A9B5-2127-A0F1-5D2807EBE780}"/>
-                  </a:ext>
-                </a:extLst>
-              </p:cNvPr>
-              <p:cNvSpPr/>
-              <p:nvPr/>
-            </p:nvSpPr>
-            <p:spPr>
-              <a:xfrm>
-                <a:off x="5645788" y="5134006"/>
-                <a:ext cx="232268" cy="173736"/>
-              </a:xfrm>
-              <a:prstGeom prst="rightArrow">
-                <a:avLst/>
-              </a:prstGeom>
-              <a:solidFill>
-                <a:srgbClr val="EDB829"/>
-              </a:solidFill>
-              <a:ln w="3175">
-                <a:solidFill>
-                  <a:schemeClr val="tx1"/>
-                </a:solidFill>
-              </a:ln>
-            </p:spPr>
-            <p:style>
-              <a:lnRef idx="2">
-                <a:schemeClr val="accent1">
-                  <a:shade val="15000"/>
-                </a:schemeClr>
-              </a:lnRef>
-              <a:fillRef idx="1">
-                <a:schemeClr val="accent1"/>
-              </a:fillRef>
-              <a:effectRef idx="0">
-                <a:schemeClr val="accent1"/>
-              </a:effectRef>
-              <a:fontRef idx="minor">
-                <a:schemeClr val="lt1"/>
-              </a:fontRef>
-            </p:style>
-            <p:txBody>
-              <a:bodyPr rtlCol="0" anchor="ctr"/>
-              <a:lstStyle/>
-              <a:p>
-                <a:pPr algn="ctr"/>
-                <a:endParaRPr lang="en-US"/>
-              </a:p>
-            </p:txBody>
-          </p:sp>
-          <p:sp>
-            <p:nvSpPr>
-              <p:cNvPr id="93" name="Right Arrow 92">
-                <a:extLst>
-                  <a:ext uri="{FF2B5EF4-FFF2-40B4-BE49-F238E27FC236}">
-                    <a16:creationId xmlns:a16="http://schemas.microsoft.com/office/drawing/2014/main" id="{CCA42299-8E3B-CA5B-0CE7-82509B938F2B}"/>
-                  </a:ext>
-                </a:extLst>
-              </p:cNvPr>
-              <p:cNvSpPr/>
-              <p:nvPr/>
-            </p:nvSpPr>
-            <p:spPr>
-              <a:xfrm>
-                <a:off x="5653649" y="5452606"/>
-                <a:ext cx="232268" cy="210312"/>
-              </a:xfrm>
-              <a:prstGeom prst="rightArrow">
-                <a:avLst/>
-              </a:prstGeom>
-              <a:solidFill>
-                <a:srgbClr val="EDB829"/>
-              </a:solidFill>
-              <a:ln w="15875">
-                <a:solidFill>
-                  <a:srgbClr val="C00000"/>
-                </a:solidFill>
+              <a:ln>
+                <a:noFill/>
               </a:ln>
             </p:spPr>
             <p:style>
@@ -4055,7 +3367,7 @@
           </p:nvSpPr>
           <p:spPr>
             <a:xfrm>
-              <a:off x="635413" y="629980"/>
+              <a:off x="668982" y="629980"/>
               <a:ext cx="2872629" cy="5760640"/>
             </a:xfrm>
             <a:prstGeom prst="rect">
@@ -4093,44 +3405,612 @@
             </a:p>
           </p:txBody>
         </p:sp>
-        <p:sp>
-          <p:nvSpPr>
-            <p:cNvPr id="97" name="TextBox 96">
+        <p:grpSp>
+          <p:nvGrpSpPr>
+            <p:cNvPr id="12" name="Group 11">
               <a:extLst>
                 <a:ext uri="{FF2B5EF4-FFF2-40B4-BE49-F238E27FC236}">
-                  <a16:creationId xmlns:a16="http://schemas.microsoft.com/office/drawing/2014/main" id="{9543B056-7D7B-0389-6F20-CF9C830C2F6D}"/>
+                  <a16:creationId xmlns:a16="http://schemas.microsoft.com/office/drawing/2014/main" id="{2B1BED21-7B93-FF2B-99EB-15F4FEBD64F7}"/>
                 </a:ext>
               </a:extLst>
             </p:cNvPr>
-            <p:cNvSpPr txBox="1"/>
+            <p:cNvGrpSpPr/>
             <p:nvPr/>
-          </p:nvSpPr>
-          <p:spPr>
+          </p:nvGrpSpPr>
+          <p:grpSpPr>
             <a:xfrm>
-              <a:off x="544124" y="260648"/>
-              <a:ext cx="1980029" cy="369332"/>
+              <a:off x="3565483" y="751065"/>
+              <a:ext cx="5098311" cy="2676281"/>
+              <a:chOff x="3565483" y="751065"/>
+              <a:chExt cx="5098311" cy="2676281"/>
             </a:xfrm>
-            <a:prstGeom prst="rect">
-              <a:avLst/>
-            </a:prstGeom>
-            <a:noFill/>
-          </p:spPr>
-          <p:txBody>
-            <a:bodyPr wrap="square" rtlCol="0">
-              <a:spAutoFit/>
-            </a:bodyPr>
-            <a:lstStyle/>
-            <a:p>
-              <a:r>
-                <a:rPr lang="en-US" dirty="0">
-                  <a:latin typeface="Helvetica" pitchFamily="2" charset="0"/>
-                  <a:cs typeface="Arial" panose="020B0604020202020204" pitchFamily="34" charset="0"/>
-                </a:rPr>
-                <a:t>a) Decomposition</a:t>
-              </a:r>
-            </a:p>
-          </p:txBody>
-        </p:sp>
+          </p:grpSpPr>
+          <p:grpSp>
+            <p:nvGrpSpPr>
+              <p:cNvPr id="4" name="Group 3">
+                <a:extLst>
+                  <a:ext uri="{FF2B5EF4-FFF2-40B4-BE49-F238E27FC236}">
+                    <a16:creationId xmlns:a16="http://schemas.microsoft.com/office/drawing/2014/main" id="{B3A20E04-6E01-7B6D-E250-7815802ACCF8}"/>
+                  </a:ext>
+                </a:extLst>
+              </p:cNvPr>
+              <p:cNvGrpSpPr/>
+              <p:nvPr/>
+            </p:nvGrpSpPr>
+            <p:grpSpPr>
+              <a:xfrm>
+                <a:off x="3571964" y="751065"/>
+                <a:ext cx="5091830" cy="1371600"/>
+                <a:chOff x="3544253" y="2875920"/>
+                <a:chExt cx="5091830" cy="1371600"/>
+              </a:xfrm>
+            </p:grpSpPr>
+            <p:pic>
+              <p:nvPicPr>
+                <p:cNvPr id="61" name="Picture 60" descr="A graph showing a line and time&#10;&#10;Description automatically generated with medium confidence">
+                  <a:extLst>
+                    <a:ext uri="{FF2B5EF4-FFF2-40B4-BE49-F238E27FC236}">
+                      <a16:creationId xmlns:a16="http://schemas.microsoft.com/office/drawing/2014/main" id="{866762CA-586C-B34C-AB73-9E48EC542420}"/>
+                    </a:ext>
+                  </a:extLst>
+                </p:cNvPr>
+                <p:cNvPicPr>
+                  <a:picLocks noChangeAspect="1"/>
+                </p:cNvPicPr>
+                <p:nvPr/>
+              </p:nvPicPr>
+              <p:blipFill>
+                <a:blip r:embed="rId4">
+                  <a:extLst>
+                    <a:ext uri="{28A0092B-C50C-407E-A947-70E740481C1C}">
+                      <a14:useLocalDpi xmlns:a14="http://schemas.microsoft.com/office/drawing/2010/main" val="0"/>
+                    </a:ext>
+                  </a:extLst>
+                </a:blip>
+                <a:stretch>
+                  <a:fillRect/>
+                </a:stretch>
+              </p:blipFill>
+              <p:spPr>
+                <a:xfrm>
+                  <a:off x="5892883" y="2875920"/>
+                  <a:ext cx="2743200" cy="1371600"/>
+                </a:xfrm>
+                <a:prstGeom prst="rect">
+                  <a:avLst/>
+                </a:prstGeom>
+              </p:spPr>
+            </p:pic>
+            <p:grpSp>
+              <p:nvGrpSpPr>
+                <p:cNvPr id="55" name="Group 54">
+                  <a:extLst>
+                    <a:ext uri="{FF2B5EF4-FFF2-40B4-BE49-F238E27FC236}">
+                      <a16:creationId xmlns:a16="http://schemas.microsoft.com/office/drawing/2014/main" id="{99DAD50E-7A2B-7192-B6B4-C42B40D55331}"/>
+                    </a:ext>
+                  </a:extLst>
+                </p:cNvPr>
+                <p:cNvGrpSpPr/>
+                <p:nvPr/>
+              </p:nvGrpSpPr>
+              <p:grpSpPr>
+                <a:xfrm>
+                  <a:off x="3544253" y="3067474"/>
+                  <a:ext cx="2128513" cy="736774"/>
+                  <a:chOff x="3064000" y="2379140"/>
+                  <a:chExt cx="3007616" cy="736774"/>
+                </a:xfrm>
+              </p:grpSpPr>
+              <p:pic>
+                <p:nvPicPr>
+                  <p:cNvPr id="53" name="Picture 52" descr="A set of colorful lines&#10;&#10;Description automatically generated with medium confidence">
+                    <a:extLst>
+                      <a:ext uri="{FF2B5EF4-FFF2-40B4-BE49-F238E27FC236}">
+                        <a16:creationId xmlns:a16="http://schemas.microsoft.com/office/drawing/2014/main" id="{4FC52D71-2FE1-0D61-3BC0-8B623942261F}"/>
+                      </a:ext>
+                    </a:extLst>
+                  </p:cNvPr>
+                  <p:cNvPicPr>
+                    <a:picLocks noChangeAspect="1"/>
+                  </p:cNvPicPr>
+                  <p:nvPr/>
+                </p:nvPicPr>
+                <p:blipFill rotWithShape="1">
+                  <a:blip r:embed="rId3">
+                    <a:extLst>
+                      <a:ext uri="{28A0092B-C50C-407E-A947-70E740481C1C}">
+                        <a14:useLocalDpi xmlns:a14="http://schemas.microsoft.com/office/drawing/2010/main" val="0"/>
+                      </a:ext>
+                    </a:extLst>
+                  </a:blip>
+                  <a:srcRect t="6859" b="84446"/>
+                  <a:stretch/>
+                </p:blipFill>
+                <p:spPr>
+                  <a:xfrm>
+                    <a:off x="3072384" y="2379140"/>
+                    <a:ext cx="2999232" cy="356592"/>
+                  </a:xfrm>
+                  <a:prstGeom prst="rect">
+                    <a:avLst/>
+                  </a:prstGeom>
+                </p:spPr>
+              </p:pic>
+              <p:pic>
+                <p:nvPicPr>
+                  <p:cNvPr id="54" name="Picture 53" descr="A set of colorful lines&#10;&#10;Description automatically generated with medium confidence">
+                    <a:extLst>
+                      <a:ext uri="{FF2B5EF4-FFF2-40B4-BE49-F238E27FC236}">
+                        <a16:creationId xmlns:a16="http://schemas.microsoft.com/office/drawing/2014/main" id="{908DEEE1-9B1C-EFCC-4B5F-FC7900478E6E}"/>
+                      </a:ext>
+                    </a:extLst>
+                  </p:cNvPr>
+                  <p:cNvPicPr>
+                    <a:picLocks noChangeAspect="1"/>
+                  </p:cNvPicPr>
+                  <p:nvPr/>
+                </p:nvPicPr>
+                <p:blipFill rotWithShape="1">
+                  <a:blip r:embed="rId3">
+                    <a:extLst>
+                      <a:ext uri="{28A0092B-C50C-407E-A947-70E740481C1C}">
+                        <a14:useLocalDpi xmlns:a14="http://schemas.microsoft.com/office/drawing/2010/main" val="0"/>
+                      </a:ext>
+                    </a:extLst>
+                  </a:blip>
+                  <a:srcRect t="15356" b="75949"/>
+                  <a:stretch/>
+                </p:blipFill>
+                <p:spPr>
+                  <a:xfrm>
+                    <a:off x="3064000" y="2759322"/>
+                    <a:ext cx="2999232" cy="356592"/>
+                  </a:xfrm>
+                  <a:prstGeom prst="rect">
+                    <a:avLst/>
+                  </a:prstGeom>
+                </p:spPr>
+              </p:pic>
+            </p:grpSp>
+            <p:sp>
+              <p:nvSpPr>
+                <p:cNvPr id="87" name="Right Arrow 86">
+                  <a:extLst>
+                    <a:ext uri="{FF2B5EF4-FFF2-40B4-BE49-F238E27FC236}">
+                      <a16:creationId xmlns:a16="http://schemas.microsoft.com/office/drawing/2014/main" id="{FCA32D21-A010-E8A2-1053-513A97B98695}"/>
+                    </a:ext>
+                  </a:extLst>
+                </p:cNvPr>
+                <p:cNvSpPr/>
+                <p:nvPr/>
+              </p:nvSpPr>
+              <p:spPr>
+                <a:xfrm>
+                  <a:off x="5653591" y="3158902"/>
+                  <a:ext cx="232268" cy="173736"/>
+                </a:xfrm>
+                <a:prstGeom prst="rightArrow">
+                  <a:avLst/>
+                </a:prstGeom>
+                <a:solidFill>
+                  <a:srgbClr val="00496F"/>
+                </a:solidFill>
+                <a:ln w="15875">
+                  <a:solidFill>
+                    <a:schemeClr val="tx1"/>
+                  </a:solidFill>
+                </a:ln>
+              </p:spPr>
+              <p:style>
+                <a:lnRef idx="2">
+                  <a:schemeClr val="accent1">
+                    <a:shade val="15000"/>
+                  </a:schemeClr>
+                </a:lnRef>
+                <a:fillRef idx="1">
+                  <a:schemeClr val="accent1"/>
+                </a:fillRef>
+                <a:effectRef idx="0">
+                  <a:schemeClr val="accent1"/>
+                </a:effectRef>
+                <a:fontRef idx="minor">
+                  <a:schemeClr val="lt1"/>
+                </a:fontRef>
+              </p:style>
+              <p:txBody>
+                <a:bodyPr rtlCol="0" anchor="ctr"/>
+                <a:lstStyle/>
+                <a:p>
+                  <a:pPr algn="ctr"/>
+                  <a:endParaRPr lang="en-US" dirty="0"/>
+                </a:p>
+              </p:txBody>
+            </p:sp>
+            <p:sp>
+              <p:nvSpPr>
+                <p:cNvPr id="88" name="Right Arrow 87">
+                  <a:extLst>
+                    <a:ext uri="{FF2B5EF4-FFF2-40B4-BE49-F238E27FC236}">
+                      <a16:creationId xmlns:a16="http://schemas.microsoft.com/office/drawing/2014/main" id="{8824C285-2611-8FF9-70B2-10C200B339F9}"/>
+                    </a:ext>
+                  </a:extLst>
+                </p:cNvPr>
+                <p:cNvSpPr/>
+                <p:nvPr/>
+              </p:nvSpPr>
+              <p:spPr>
+                <a:xfrm>
+                  <a:off x="5647030" y="3603821"/>
+                  <a:ext cx="232268" cy="73152"/>
+                </a:xfrm>
+                <a:prstGeom prst="rightArrow">
+                  <a:avLst/>
+                </a:prstGeom>
+                <a:solidFill>
+                  <a:srgbClr val="0C7996"/>
+                </a:solidFill>
+                <a:ln w="15875">
+                  <a:solidFill>
+                    <a:schemeClr val="tx1"/>
+                  </a:solidFill>
+                </a:ln>
+              </p:spPr>
+              <p:style>
+                <a:lnRef idx="2">
+                  <a:schemeClr val="accent1">
+                    <a:shade val="15000"/>
+                  </a:schemeClr>
+                </a:lnRef>
+                <a:fillRef idx="1">
+                  <a:schemeClr val="accent1"/>
+                </a:fillRef>
+                <a:effectRef idx="0">
+                  <a:schemeClr val="accent1"/>
+                </a:effectRef>
+                <a:fontRef idx="minor">
+                  <a:schemeClr val="lt1"/>
+                </a:fontRef>
+              </p:style>
+              <p:txBody>
+                <a:bodyPr rtlCol="0" anchor="ctr"/>
+                <a:lstStyle/>
+                <a:p>
+                  <a:pPr algn="ctr"/>
+                  <a:endParaRPr lang="en-US"/>
+                </a:p>
+              </p:txBody>
+            </p:sp>
+          </p:grpSp>
+          <p:grpSp>
+            <p:nvGrpSpPr>
+              <p:cNvPr id="3" name="Group 2">
+                <a:extLst>
+                  <a:ext uri="{FF2B5EF4-FFF2-40B4-BE49-F238E27FC236}">
+                    <a16:creationId xmlns:a16="http://schemas.microsoft.com/office/drawing/2014/main" id="{CF54F3C6-E541-849F-0EDB-886867563FF0}"/>
+                  </a:ext>
+                </a:extLst>
+              </p:cNvPr>
+              <p:cNvGrpSpPr/>
+              <p:nvPr/>
+            </p:nvGrpSpPr>
+            <p:grpSpPr>
+              <a:xfrm>
+                <a:off x="3565483" y="2055746"/>
+                <a:ext cx="5093985" cy="1371600"/>
+                <a:chOff x="3537058" y="1206044"/>
+                <a:chExt cx="5093985" cy="1371600"/>
+              </a:xfrm>
+            </p:grpSpPr>
+            <p:pic>
+              <p:nvPicPr>
+                <p:cNvPr id="59" name="Picture 58" descr="A graph showing a line&#10;&#10;Description automatically generated with medium confidence">
+                  <a:extLst>
+                    <a:ext uri="{FF2B5EF4-FFF2-40B4-BE49-F238E27FC236}">
+                      <a16:creationId xmlns:a16="http://schemas.microsoft.com/office/drawing/2014/main" id="{4F18A0D3-4D6F-7AF3-BAEA-0FF0E2C4E3A0}"/>
+                    </a:ext>
+                  </a:extLst>
+                </p:cNvPr>
+                <p:cNvPicPr>
+                  <a:picLocks noChangeAspect="1"/>
+                </p:cNvPicPr>
+                <p:nvPr/>
+              </p:nvPicPr>
+              <p:blipFill>
+                <a:blip r:embed="rId5">
+                  <a:extLst>
+                    <a:ext uri="{28A0092B-C50C-407E-A947-70E740481C1C}">
+                      <a14:useLocalDpi xmlns:a14="http://schemas.microsoft.com/office/drawing/2010/main" val="0"/>
+                    </a:ext>
+                  </a:extLst>
+                </a:blip>
+                <a:stretch>
+                  <a:fillRect/>
+                </a:stretch>
+              </p:blipFill>
+              <p:spPr>
+                <a:xfrm>
+                  <a:off x="5887843" y="1206044"/>
+                  <a:ext cx="2743200" cy="1371600"/>
+                </a:xfrm>
+                <a:prstGeom prst="rect">
+                  <a:avLst/>
+                </a:prstGeom>
+              </p:spPr>
+            </p:pic>
+            <p:grpSp>
+              <p:nvGrpSpPr>
+                <p:cNvPr id="2" name="Group 1">
+                  <a:extLst>
+                    <a:ext uri="{FF2B5EF4-FFF2-40B4-BE49-F238E27FC236}">
+                      <a16:creationId xmlns:a16="http://schemas.microsoft.com/office/drawing/2014/main" id="{ED3E23CA-2CEE-E1D1-31C2-DEBC3F9BAB37}"/>
+                    </a:ext>
+                  </a:extLst>
+                </p:cNvPr>
+                <p:cNvGrpSpPr/>
+                <p:nvPr/>
+              </p:nvGrpSpPr>
+              <p:grpSpPr>
+                <a:xfrm>
+                  <a:off x="3537058" y="1437204"/>
+                  <a:ext cx="2348844" cy="713184"/>
+                  <a:chOff x="3537058" y="1437204"/>
+                  <a:chExt cx="2348844" cy="713184"/>
+                </a:xfrm>
+              </p:grpSpPr>
+              <p:grpSp>
+                <p:nvGrpSpPr>
+                  <p:cNvPr id="52" name="Group 51">
+                    <a:extLst>
+                      <a:ext uri="{FF2B5EF4-FFF2-40B4-BE49-F238E27FC236}">
+                        <a16:creationId xmlns:a16="http://schemas.microsoft.com/office/drawing/2014/main" id="{20374367-B742-193E-1A0B-914729C24DA8}"/>
+                      </a:ext>
+                    </a:extLst>
+                  </p:cNvPr>
+                  <p:cNvGrpSpPr/>
+                  <p:nvPr/>
+                </p:nvGrpSpPr>
+                <p:grpSpPr>
+                  <a:xfrm>
+                    <a:off x="3537058" y="1437204"/>
+                    <a:ext cx="2128512" cy="713184"/>
+                    <a:chOff x="3174888" y="1268760"/>
+                    <a:chExt cx="2999232" cy="713184"/>
+                  </a:xfrm>
+                </p:grpSpPr>
+                <p:pic>
+                  <p:nvPicPr>
+                    <p:cNvPr id="48" name="Picture 47" descr="A set of colorful lines&#10;&#10;Description automatically generated with medium confidence">
+                      <a:extLst>
+                        <a:ext uri="{FF2B5EF4-FFF2-40B4-BE49-F238E27FC236}">
+                          <a16:creationId xmlns:a16="http://schemas.microsoft.com/office/drawing/2014/main" id="{0A5EFB53-9B99-460E-4837-3F4E961E8928}"/>
+                        </a:ext>
+                      </a:extLst>
+                    </p:cNvPr>
+                    <p:cNvPicPr>
+                      <a:picLocks noChangeAspect="1"/>
+                    </p:cNvPicPr>
+                    <p:nvPr/>
+                  </p:nvPicPr>
+                  <p:blipFill rotWithShape="1">
+                    <a:blip r:embed="rId3">
+                      <a:extLst>
+                        <a:ext uri="{28A0092B-C50C-407E-A947-70E740481C1C}">
+                          <a14:useLocalDpi xmlns:a14="http://schemas.microsoft.com/office/drawing/2010/main" val="0"/>
+                        </a:ext>
+                      </a:extLst>
+                    </a:blip>
+                    <a:srcRect b="91305"/>
+                    <a:stretch/>
+                  </p:blipFill>
+                  <p:spPr>
+                    <a:xfrm>
+                      <a:off x="3174888" y="1268760"/>
+                      <a:ext cx="2999232" cy="356592"/>
+                    </a:xfrm>
+                    <a:prstGeom prst="rect">
+                      <a:avLst/>
+                    </a:prstGeom>
+                  </p:spPr>
+                </p:pic>
+                <p:pic>
+                  <p:nvPicPr>
+                    <p:cNvPr id="51" name="Picture 50" descr="A set of colorful lines&#10;&#10;Description automatically generated with medium confidence">
+                      <a:extLst>
+                        <a:ext uri="{FF2B5EF4-FFF2-40B4-BE49-F238E27FC236}">
+                          <a16:creationId xmlns:a16="http://schemas.microsoft.com/office/drawing/2014/main" id="{6D3A3A9D-0122-82E9-B566-44C8A7AB2728}"/>
+                        </a:ext>
+                      </a:extLst>
+                    </p:cNvPr>
+                    <p:cNvPicPr>
+                      <a:picLocks noChangeAspect="1"/>
+                    </p:cNvPicPr>
+                    <p:nvPr/>
+                  </p:nvPicPr>
+                  <p:blipFill rotWithShape="1">
+                    <a:blip r:embed="rId3">
+                      <a:extLst>
+                        <a:ext uri="{28A0092B-C50C-407E-A947-70E740481C1C}">
+                          <a14:useLocalDpi xmlns:a14="http://schemas.microsoft.com/office/drawing/2010/main" val="0"/>
+                        </a:ext>
+                      </a:extLst>
+                    </a:blip>
+                    <a:srcRect t="64340" b="26965"/>
+                    <a:stretch/>
+                  </p:blipFill>
+                  <p:spPr>
+                    <a:xfrm>
+                      <a:off x="3174888" y="1625352"/>
+                      <a:ext cx="2999232" cy="356592"/>
+                    </a:xfrm>
+                    <a:prstGeom prst="rect">
+                      <a:avLst/>
+                    </a:prstGeom>
+                  </p:spPr>
+                </p:pic>
+              </p:grpSp>
+              <p:sp>
+                <p:nvSpPr>
+                  <p:cNvPr id="85" name="Right Arrow 84">
+                    <a:extLst>
+                      <a:ext uri="{FF2B5EF4-FFF2-40B4-BE49-F238E27FC236}">
+                        <a16:creationId xmlns:a16="http://schemas.microsoft.com/office/drawing/2014/main" id="{7DFE395F-4AF2-0B3D-3B33-EBBB8DFB2039}"/>
+                      </a:ext>
+                    </a:extLst>
+                  </p:cNvPr>
+                  <p:cNvSpPr/>
+                  <p:nvPr/>
+                </p:nvSpPr>
+                <p:spPr>
+                  <a:xfrm>
+                    <a:off x="5653634" y="1438751"/>
+                    <a:ext cx="232268" cy="274320"/>
+                  </a:xfrm>
+                  <a:prstGeom prst="rightArrow">
+                    <a:avLst/>
+                  </a:prstGeom>
+                  <a:solidFill>
+                    <a:srgbClr val="00496F"/>
+                  </a:solidFill>
+                  <a:ln w="15875">
+                    <a:solidFill>
+                      <a:schemeClr val="tx1"/>
+                    </a:solidFill>
+                  </a:ln>
+                </p:spPr>
+                <p:style>
+                  <a:lnRef idx="2">
+                    <a:schemeClr val="accent1">
+                      <a:shade val="15000"/>
+                    </a:schemeClr>
+                  </a:lnRef>
+                  <a:fillRef idx="1">
+                    <a:schemeClr val="accent1"/>
+                  </a:fillRef>
+                  <a:effectRef idx="0">
+                    <a:schemeClr val="accent1"/>
+                  </a:effectRef>
+                  <a:fontRef idx="minor">
+                    <a:schemeClr val="lt1"/>
+                  </a:fontRef>
+                </p:style>
+                <p:txBody>
+                  <a:bodyPr rtlCol="0" anchor="ctr"/>
+                  <a:lstStyle/>
+                  <a:p>
+                    <a:pPr algn="ctr"/>
+                    <a:endParaRPr lang="en-US"/>
+                  </a:p>
+                </p:txBody>
+              </p:sp>
+              <p:sp>
+                <p:nvSpPr>
+                  <p:cNvPr id="86" name="Right Arrow 85">
+                    <a:extLst>
+                      <a:ext uri="{FF2B5EF4-FFF2-40B4-BE49-F238E27FC236}">
+                        <a16:creationId xmlns:a16="http://schemas.microsoft.com/office/drawing/2014/main" id="{70AEB2B5-4C1B-6AA9-EF9F-4B69ADFDDC0B}"/>
+                      </a:ext>
+                    </a:extLst>
+                  </p:cNvPr>
+                  <p:cNvSpPr/>
+                  <p:nvPr/>
+                </p:nvSpPr>
+                <p:spPr>
+                  <a:xfrm>
+                    <a:off x="5653634" y="1853237"/>
+                    <a:ext cx="232268" cy="173736"/>
+                  </a:xfrm>
+                  <a:prstGeom prst="rightArrow">
+                    <a:avLst/>
+                  </a:prstGeom>
+                  <a:solidFill>
+                    <a:srgbClr val="E97C07"/>
+                  </a:solidFill>
+                  <a:ln w="15875">
+                    <a:solidFill>
+                      <a:schemeClr val="tx1"/>
+                    </a:solidFill>
+                  </a:ln>
+                </p:spPr>
+                <p:style>
+                  <a:lnRef idx="2">
+                    <a:schemeClr val="accent1">
+                      <a:shade val="15000"/>
+                    </a:schemeClr>
+                  </a:lnRef>
+                  <a:fillRef idx="1">
+                    <a:schemeClr val="accent1"/>
+                  </a:fillRef>
+                  <a:effectRef idx="0">
+                    <a:schemeClr val="accent1"/>
+                  </a:effectRef>
+                  <a:fontRef idx="minor">
+                    <a:schemeClr val="lt1"/>
+                  </a:fontRef>
+                </p:style>
+                <p:txBody>
+                  <a:bodyPr rtlCol="0" anchor="ctr"/>
+                  <a:lstStyle/>
+                  <a:p>
+                    <a:pPr algn="ctr"/>
+                    <a:endParaRPr lang="en-US"/>
+                  </a:p>
+                </p:txBody>
+              </p:sp>
+            </p:grpSp>
+          </p:grpSp>
+          <p:sp>
+            <p:nvSpPr>
+              <p:cNvPr id="11" name="Rectangle 10">
+                <a:extLst>
+                  <a:ext uri="{FF2B5EF4-FFF2-40B4-BE49-F238E27FC236}">
+                    <a16:creationId xmlns:a16="http://schemas.microsoft.com/office/drawing/2014/main" id="{B6E3565A-87DA-9A81-A302-33FB39E1A59D}"/>
+                  </a:ext>
+                </a:extLst>
+              </p:cNvPr>
+              <p:cNvSpPr/>
+              <p:nvPr/>
+            </p:nvSpPr>
+            <p:spPr>
+              <a:xfrm>
+                <a:off x="3685972" y="836712"/>
+                <a:ext cx="93940" cy="2499777"/>
+              </a:xfrm>
+              <a:prstGeom prst="rect">
+                <a:avLst/>
+              </a:prstGeom>
+              <a:solidFill>
+                <a:schemeClr val="bg1"/>
+              </a:solidFill>
+              <a:ln>
+                <a:noFill/>
+              </a:ln>
+            </p:spPr>
+            <p:style>
+              <a:lnRef idx="2">
+                <a:schemeClr val="accent1">
+                  <a:shade val="15000"/>
+                </a:schemeClr>
+              </a:lnRef>
+              <a:fillRef idx="1">
+                <a:schemeClr val="accent1"/>
+              </a:fillRef>
+              <a:effectRef idx="0">
+                <a:schemeClr val="accent1"/>
+              </a:effectRef>
+              <a:fontRef idx="minor">
+                <a:schemeClr val="lt1"/>
+              </a:fontRef>
+            </p:style>
+            <p:txBody>
+              <a:bodyPr rtlCol="0" anchor="ctr"/>
+              <a:lstStyle/>
+              <a:p>
+                <a:pPr algn="ctr"/>
+                <a:endParaRPr lang="en-US"/>
+              </a:p>
+            </p:txBody>
+          </p:sp>
+        </p:grpSp>
         <p:sp>
           <p:nvSpPr>
             <p:cNvPr id="98" name="Rectangle 97">
@@ -4145,7 +4025,7 @@
           </p:nvSpPr>
           <p:spPr>
             <a:xfrm>
-              <a:off x="3637472" y="629980"/>
+              <a:off x="3671041" y="629980"/>
               <a:ext cx="5000544" cy="2797366"/>
             </a:xfrm>
             <a:prstGeom prst="rect">
@@ -4183,45 +4063,422 @@
             </a:p>
           </p:txBody>
         </p:sp>
-        <p:sp>
-          <p:nvSpPr>
-            <p:cNvPr id="99" name="TextBox 98">
+        <p:grpSp>
+          <p:nvGrpSpPr>
+            <p:cNvPr id="14" name="Group 13">
               <a:extLst>
                 <a:ext uri="{FF2B5EF4-FFF2-40B4-BE49-F238E27FC236}">
-                  <a16:creationId xmlns:a16="http://schemas.microsoft.com/office/drawing/2014/main" id="{48CF7F87-F487-0602-8884-FE9FE6E3A1BD}"/>
+                  <a16:creationId xmlns:a16="http://schemas.microsoft.com/office/drawing/2014/main" id="{57E53972-2B3F-38A4-08E0-5084A592EEC6}"/>
                 </a:ext>
               </a:extLst>
             </p:cNvPr>
-            <p:cNvSpPr txBox="1"/>
+            <p:cNvGrpSpPr/>
             <p:nvPr/>
-          </p:nvSpPr>
-          <p:spPr>
+          </p:nvGrpSpPr>
+          <p:grpSpPr>
             <a:xfrm>
-              <a:off x="3603188" y="260648"/>
-              <a:ext cx="3463128" cy="369332"/>
+              <a:off x="3565483" y="4032448"/>
+              <a:ext cx="5106102" cy="1526997"/>
+              <a:chOff x="3565483" y="4120644"/>
+              <a:chExt cx="5106102" cy="1526997"/>
             </a:xfrm>
-            <a:prstGeom prst="rect">
-              <a:avLst/>
-            </a:prstGeom>
-            <a:noFill/>
-          </p:spPr>
-          <p:txBody>
-            <a:bodyPr wrap="square" rtlCol="0">
-              <a:spAutoFit/>
-            </a:bodyPr>
-            <a:lstStyle/>
-            <a:p>
-              <a:pPr marL="7938"/>
-              <a:r>
-                <a:rPr lang="en-US" dirty="0">
-                  <a:latin typeface="Helvetica" pitchFamily="2" charset="0"/>
-                  <a:cs typeface="Arial" panose="020B0604020202020204" pitchFamily="34" charset="0"/>
-                </a:rPr>
-                <a:t>b) Possible linear combinations</a:t>
-              </a:r>
-            </a:p>
-          </p:txBody>
-        </p:sp>
+          </p:grpSpPr>
+          <p:grpSp>
+            <p:nvGrpSpPr>
+              <p:cNvPr id="6" name="Group 5">
+                <a:extLst>
+                  <a:ext uri="{FF2B5EF4-FFF2-40B4-BE49-F238E27FC236}">
+                    <a16:creationId xmlns:a16="http://schemas.microsoft.com/office/drawing/2014/main" id="{F91089BB-49C6-D7C8-678F-2F144AD6AD6C}"/>
+                  </a:ext>
+                </a:extLst>
+              </p:cNvPr>
+              <p:cNvGrpSpPr/>
+              <p:nvPr/>
+            </p:nvGrpSpPr>
+            <p:grpSpPr>
+              <a:xfrm>
+                <a:off x="3565483" y="4149080"/>
+                <a:ext cx="5106102" cy="1498561"/>
+                <a:chOff x="3531914" y="4045188"/>
+                <a:chExt cx="5106102" cy="1498561"/>
+              </a:xfrm>
+            </p:grpSpPr>
+            <p:pic>
+              <p:nvPicPr>
+                <p:cNvPr id="63" name="Picture 62" descr="A graph showing a line of time&#10;&#10;Description automatically generated">
+                  <a:extLst>
+                    <a:ext uri="{FF2B5EF4-FFF2-40B4-BE49-F238E27FC236}">
+                      <a16:creationId xmlns:a16="http://schemas.microsoft.com/office/drawing/2014/main" id="{4670FD12-50CE-503B-BAA7-F976D5EA3117}"/>
+                    </a:ext>
+                  </a:extLst>
+                </p:cNvPr>
+                <p:cNvPicPr>
+                  <a:picLocks noChangeAspect="1"/>
+                </p:cNvPicPr>
+                <p:nvPr/>
+              </p:nvPicPr>
+              <p:blipFill>
+                <a:blip r:embed="rId6">
+                  <a:extLst>
+                    <a:ext uri="{28A0092B-C50C-407E-A947-70E740481C1C}">
+                      <a14:useLocalDpi xmlns:a14="http://schemas.microsoft.com/office/drawing/2010/main" val="0"/>
+                    </a:ext>
+                  </a:extLst>
+                </a:blip>
+                <a:stretch>
+                  <a:fillRect/>
+                </a:stretch>
+              </p:blipFill>
+              <p:spPr>
+                <a:xfrm>
+                  <a:off x="5894816" y="4172149"/>
+                  <a:ext cx="2743200" cy="1371600"/>
+                </a:xfrm>
+                <a:prstGeom prst="rect">
+                  <a:avLst/>
+                </a:prstGeom>
+              </p:spPr>
+            </p:pic>
+            <p:pic>
+              <p:nvPicPr>
+                <p:cNvPr id="56" name="Picture 55" descr="A set of colorful lines&#10;&#10;Description automatically generated with medium confidence">
+                  <a:extLst>
+                    <a:ext uri="{FF2B5EF4-FFF2-40B4-BE49-F238E27FC236}">
+                      <a16:creationId xmlns:a16="http://schemas.microsoft.com/office/drawing/2014/main" id="{E25B4579-A89B-BBE3-0542-187D7C9A9117}"/>
+                    </a:ext>
+                  </a:extLst>
+                </p:cNvPr>
+                <p:cNvPicPr>
+                  <a:picLocks noChangeAspect="1"/>
+                </p:cNvPicPr>
+                <p:nvPr/>
+              </p:nvPicPr>
+              <p:blipFill rotWithShape="1">
+                <a:blip r:embed="rId3">
+                  <a:extLst>
+                    <a:ext uri="{28A0092B-C50C-407E-A947-70E740481C1C}">
+                      <a14:useLocalDpi xmlns:a14="http://schemas.microsoft.com/office/drawing/2010/main" val="0"/>
+                    </a:ext>
+                  </a:extLst>
+                </a:blip>
+                <a:srcRect b="83945"/>
+                <a:stretch/>
+              </p:blipFill>
+              <p:spPr>
+                <a:xfrm>
+                  <a:off x="3538395" y="4046120"/>
+                  <a:ext cx="2122579" cy="658416"/>
+                </a:xfrm>
+                <a:prstGeom prst="rect">
+                  <a:avLst/>
+                </a:prstGeom>
+              </p:spPr>
+            </p:pic>
+            <p:pic>
+              <p:nvPicPr>
+                <p:cNvPr id="57" name="Picture 56" descr="A set of colorful lines&#10;&#10;Description automatically generated with medium confidence">
+                  <a:extLst>
+                    <a:ext uri="{FF2B5EF4-FFF2-40B4-BE49-F238E27FC236}">
+                      <a16:creationId xmlns:a16="http://schemas.microsoft.com/office/drawing/2014/main" id="{184A4771-D284-7615-3F6D-49AC45E1B0A4}"/>
+                    </a:ext>
+                  </a:extLst>
+                </p:cNvPr>
+                <p:cNvPicPr>
+                  <a:picLocks noChangeAspect="1"/>
+                </p:cNvPicPr>
+                <p:nvPr/>
+              </p:nvPicPr>
+              <p:blipFill rotWithShape="1">
+                <a:blip r:embed="rId3">
+                  <a:extLst>
+                    <a:ext uri="{28A0092B-C50C-407E-A947-70E740481C1C}">
+                      <a14:useLocalDpi xmlns:a14="http://schemas.microsoft.com/office/drawing/2010/main" val="0"/>
+                    </a:ext>
+                  </a:extLst>
+                </a:blip>
+                <a:srcRect t="49023" b="35968"/>
+                <a:stretch/>
+              </p:blipFill>
+              <p:spPr>
+                <a:xfrm>
+                  <a:off x="3531914" y="4727869"/>
+                  <a:ext cx="2122579" cy="615519"/>
+                </a:xfrm>
+                <a:prstGeom prst="rect">
+                  <a:avLst/>
+                </a:prstGeom>
+              </p:spPr>
+            </p:pic>
+            <p:sp>
+              <p:nvSpPr>
+                <p:cNvPr id="89" name="Right Arrow 88">
+                  <a:extLst>
+                    <a:ext uri="{FF2B5EF4-FFF2-40B4-BE49-F238E27FC236}">
+                      <a16:creationId xmlns:a16="http://schemas.microsoft.com/office/drawing/2014/main" id="{234E50D9-1BAF-098C-89FC-B13225B68B2B}"/>
+                    </a:ext>
+                  </a:extLst>
+                </p:cNvPr>
+                <p:cNvSpPr/>
+                <p:nvPr/>
+              </p:nvSpPr>
+              <p:spPr>
+                <a:xfrm>
+                  <a:off x="5653591" y="4045188"/>
+                  <a:ext cx="232268" cy="274320"/>
+                </a:xfrm>
+                <a:prstGeom prst="rightArrow">
+                  <a:avLst/>
+                </a:prstGeom>
+                <a:solidFill>
+                  <a:srgbClr val="00496F"/>
+                </a:solidFill>
+                <a:ln w="15875">
+                  <a:solidFill>
+                    <a:schemeClr val="tx1"/>
+                  </a:solidFill>
+                </a:ln>
+              </p:spPr>
+              <p:style>
+                <a:lnRef idx="2">
+                  <a:schemeClr val="accent1">
+                    <a:shade val="15000"/>
+                  </a:schemeClr>
+                </a:lnRef>
+                <a:fillRef idx="1">
+                  <a:schemeClr val="accent1"/>
+                </a:fillRef>
+                <a:effectRef idx="0">
+                  <a:schemeClr val="accent1"/>
+                </a:effectRef>
+                <a:fontRef idx="minor">
+                  <a:schemeClr val="lt1"/>
+                </a:fontRef>
+              </p:style>
+              <p:txBody>
+                <a:bodyPr rtlCol="0" anchor="ctr"/>
+                <a:lstStyle/>
+                <a:p>
+                  <a:pPr algn="ctr"/>
+                  <a:endParaRPr lang="en-US"/>
+                </a:p>
+              </p:txBody>
+            </p:sp>
+            <p:sp>
+              <p:nvSpPr>
+                <p:cNvPr id="91" name="Right Arrow 90">
+                  <a:extLst>
+                    <a:ext uri="{FF2B5EF4-FFF2-40B4-BE49-F238E27FC236}">
+                      <a16:creationId xmlns:a16="http://schemas.microsoft.com/office/drawing/2014/main" id="{14E1EBDB-0F05-B4AC-8EDA-B7A3BAFAA3F8}"/>
+                    </a:ext>
+                  </a:extLst>
+                </p:cNvPr>
+                <p:cNvSpPr/>
+                <p:nvPr/>
+              </p:nvSpPr>
+              <p:spPr>
+                <a:xfrm>
+                  <a:off x="5647030" y="4480222"/>
+                  <a:ext cx="232268" cy="73152"/>
+                </a:xfrm>
+                <a:prstGeom prst="rightArrow">
+                  <a:avLst/>
+                </a:prstGeom>
+                <a:solidFill>
+                  <a:srgbClr val="00496F"/>
+                </a:solidFill>
+                <a:ln w="15875">
+                  <a:solidFill>
+                    <a:schemeClr val="tx1"/>
+                  </a:solidFill>
+                </a:ln>
+              </p:spPr>
+              <p:style>
+                <a:lnRef idx="2">
+                  <a:schemeClr val="accent1">
+                    <a:shade val="15000"/>
+                  </a:schemeClr>
+                </a:lnRef>
+                <a:fillRef idx="1">
+                  <a:schemeClr val="accent1"/>
+                </a:fillRef>
+                <a:effectRef idx="0">
+                  <a:schemeClr val="accent1"/>
+                </a:effectRef>
+                <a:fontRef idx="minor">
+                  <a:schemeClr val="lt1"/>
+                </a:fontRef>
+              </p:style>
+              <p:txBody>
+                <a:bodyPr rtlCol="0" anchor="ctr"/>
+                <a:lstStyle/>
+                <a:p>
+                  <a:pPr algn="ctr"/>
+                  <a:endParaRPr lang="en-US"/>
+                </a:p>
+              </p:txBody>
+            </p:sp>
+            <p:sp>
+              <p:nvSpPr>
+                <p:cNvPr id="92" name="Right Arrow 91">
+                  <a:extLst>
+                    <a:ext uri="{FF2B5EF4-FFF2-40B4-BE49-F238E27FC236}">
+                      <a16:creationId xmlns:a16="http://schemas.microsoft.com/office/drawing/2014/main" id="{528F1F8F-A9B5-2127-A0F1-5D2807EBE780}"/>
+                    </a:ext>
+                  </a:extLst>
+                </p:cNvPr>
+                <p:cNvSpPr/>
+                <p:nvPr/>
+              </p:nvSpPr>
+              <p:spPr>
+                <a:xfrm>
+                  <a:off x="5645788" y="4760359"/>
+                  <a:ext cx="232268" cy="173736"/>
+                </a:xfrm>
+                <a:prstGeom prst="rightArrow">
+                  <a:avLst/>
+                </a:prstGeom>
+                <a:solidFill>
+                  <a:srgbClr val="EDB829"/>
+                </a:solidFill>
+                <a:ln w="15875">
+                  <a:solidFill>
+                    <a:schemeClr val="tx1"/>
+                  </a:solidFill>
+                </a:ln>
+              </p:spPr>
+              <p:style>
+                <a:lnRef idx="2">
+                  <a:schemeClr val="accent1">
+                    <a:shade val="15000"/>
+                  </a:schemeClr>
+                </a:lnRef>
+                <a:fillRef idx="1">
+                  <a:schemeClr val="accent1"/>
+                </a:fillRef>
+                <a:effectRef idx="0">
+                  <a:schemeClr val="accent1"/>
+                </a:effectRef>
+                <a:fontRef idx="minor">
+                  <a:schemeClr val="lt1"/>
+                </a:fontRef>
+              </p:style>
+              <p:txBody>
+                <a:bodyPr rtlCol="0" anchor="ctr"/>
+                <a:lstStyle/>
+                <a:p>
+                  <a:pPr algn="ctr"/>
+                  <a:endParaRPr lang="en-US"/>
+                </a:p>
+              </p:txBody>
+            </p:sp>
+            <p:sp>
+              <p:nvSpPr>
+                <p:cNvPr id="93" name="Right Arrow 92">
+                  <a:extLst>
+                    <a:ext uri="{FF2B5EF4-FFF2-40B4-BE49-F238E27FC236}">
+                      <a16:creationId xmlns:a16="http://schemas.microsoft.com/office/drawing/2014/main" id="{CCA42299-8E3B-CA5B-0CE7-82509B938F2B}"/>
+                    </a:ext>
+                  </a:extLst>
+                </p:cNvPr>
+                <p:cNvSpPr/>
+                <p:nvPr/>
+              </p:nvSpPr>
+              <p:spPr>
+                <a:xfrm>
+                  <a:off x="5653649" y="5078959"/>
+                  <a:ext cx="232268" cy="210312"/>
+                </a:xfrm>
+                <a:prstGeom prst="rightArrow">
+                  <a:avLst/>
+                </a:prstGeom>
+                <a:solidFill>
+                  <a:srgbClr val="EDB829"/>
+                </a:solidFill>
+                <a:ln w="15875">
+                  <a:solidFill>
+                    <a:srgbClr val="C00000"/>
+                  </a:solidFill>
+                </a:ln>
+              </p:spPr>
+              <p:style>
+                <a:lnRef idx="2">
+                  <a:schemeClr val="accent1">
+                    <a:shade val="15000"/>
+                  </a:schemeClr>
+                </a:lnRef>
+                <a:fillRef idx="1">
+                  <a:schemeClr val="accent1"/>
+                </a:fillRef>
+                <a:effectRef idx="0">
+                  <a:schemeClr val="accent1"/>
+                </a:effectRef>
+                <a:fontRef idx="minor">
+                  <a:schemeClr val="lt1"/>
+                </a:fontRef>
+              </p:style>
+              <p:txBody>
+                <a:bodyPr rtlCol="0" anchor="ctr"/>
+                <a:lstStyle/>
+                <a:p>
+                  <a:pPr algn="ctr"/>
+                  <a:endParaRPr lang="en-US"/>
+                </a:p>
+              </p:txBody>
+            </p:sp>
+          </p:grpSp>
+          <p:sp>
+            <p:nvSpPr>
+              <p:cNvPr id="13" name="Rectangle 12">
+                <a:extLst>
+                  <a:ext uri="{FF2B5EF4-FFF2-40B4-BE49-F238E27FC236}">
+                    <a16:creationId xmlns:a16="http://schemas.microsoft.com/office/drawing/2014/main" id="{702782D2-7BC1-1D05-B595-52B36D3C1E33}"/>
+                  </a:ext>
+                </a:extLst>
+              </p:cNvPr>
+              <p:cNvSpPr/>
+              <p:nvPr/>
+            </p:nvSpPr>
+            <p:spPr>
+              <a:xfrm>
+                <a:off x="3705942" y="4120644"/>
+                <a:ext cx="93940" cy="1371600"/>
+              </a:xfrm>
+              <a:prstGeom prst="rect">
+                <a:avLst/>
+              </a:prstGeom>
+              <a:solidFill>
+                <a:schemeClr val="bg1"/>
+              </a:solidFill>
+              <a:ln>
+                <a:noFill/>
+              </a:ln>
+            </p:spPr>
+            <p:style>
+              <a:lnRef idx="2">
+                <a:schemeClr val="accent1">
+                  <a:shade val="15000"/>
+                </a:schemeClr>
+              </a:lnRef>
+              <a:fillRef idx="1">
+                <a:schemeClr val="accent1"/>
+              </a:fillRef>
+              <a:effectRef idx="0">
+                <a:schemeClr val="accent1"/>
+              </a:effectRef>
+              <a:fontRef idx="minor">
+                <a:schemeClr val="lt1"/>
+              </a:fontRef>
+            </p:style>
+            <p:txBody>
+              <a:bodyPr rtlCol="0" anchor="ctr"/>
+              <a:lstStyle/>
+              <a:p>
+                <a:pPr algn="ctr"/>
+                <a:endParaRPr lang="en-US"/>
+              </a:p>
+            </p:txBody>
+          </p:sp>
+        </p:grpSp>
         <p:sp>
           <p:nvSpPr>
             <p:cNvPr id="5" name="Rectangle 4">
@@ -4236,8 +4493,8 @@
           </p:nvSpPr>
           <p:spPr>
             <a:xfrm>
-              <a:off x="3652403" y="4034859"/>
-              <a:ext cx="5000544" cy="2358294"/>
+              <a:off x="3685972" y="3933056"/>
+              <a:ext cx="5000544" cy="1635681"/>
             </a:xfrm>
             <a:prstGeom prst="rect">
               <a:avLst/>
@@ -4270,16 +4527,120 @@
             <a:lstStyle/>
             <a:p>
               <a:pPr algn="ctr"/>
+              <a:endParaRPr lang="en-US" dirty="0"/>
+            </a:p>
+          </p:txBody>
+        </p:sp>
+        <p:sp>
+          <p:nvSpPr>
+            <p:cNvPr id="15" name="Right Arrow 14">
+              <a:extLst>
+                <a:ext uri="{FF2B5EF4-FFF2-40B4-BE49-F238E27FC236}">
+                  <a16:creationId xmlns:a16="http://schemas.microsoft.com/office/drawing/2014/main" id="{DA297C0A-3032-2E42-A0E1-0FB6E3B3ADD6}"/>
+                </a:ext>
+              </a:extLst>
+            </p:cNvPr>
+            <p:cNvSpPr/>
+            <p:nvPr/>
+          </p:nvSpPr>
+          <p:spPr>
+            <a:xfrm>
+              <a:off x="3989614" y="5760213"/>
+              <a:ext cx="232268" cy="210312"/>
+            </a:xfrm>
+            <a:prstGeom prst="rightArrow">
+              <a:avLst/>
+            </a:prstGeom>
+            <a:noFill/>
+            <a:ln w="15875">
+              <a:solidFill>
+                <a:schemeClr val="tx1"/>
+              </a:solidFill>
+            </a:ln>
+          </p:spPr>
+          <p:style>
+            <a:lnRef idx="2">
+              <a:schemeClr val="accent1">
+                <a:shade val="15000"/>
+              </a:schemeClr>
+            </a:lnRef>
+            <a:fillRef idx="1">
+              <a:schemeClr val="accent1"/>
+            </a:fillRef>
+            <a:effectRef idx="0">
+              <a:schemeClr val="accent1"/>
+            </a:effectRef>
+            <a:fontRef idx="minor">
+              <a:schemeClr val="lt1"/>
+            </a:fontRef>
+          </p:style>
+          <p:txBody>
+            <a:bodyPr rtlCol="0" anchor="ctr"/>
+            <a:lstStyle/>
+            <a:p>
+              <a:pPr algn="ctr"/>
               <a:endParaRPr lang="en-US"/>
             </a:p>
           </p:txBody>
         </p:sp>
         <p:sp>
           <p:nvSpPr>
-            <p:cNvPr id="7" name="TextBox 6">
+            <p:cNvPr id="16" name="Right Arrow 15">
               <a:extLst>
                 <a:ext uri="{FF2B5EF4-FFF2-40B4-BE49-F238E27FC236}">
-                  <a16:creationId xmlns:a16="http://schemas.microsoft.com/office/drawing/2014/main" id="{982298F3-2624-FF75-8CDA-577D01C92BE0}"/>
+                  <a16:creationId xmlns:a16="http://schemas.microsoft.com/office/drawing/2014/main" id="{E64905C3-31B7-08B4-2B73-207C1CE94FE5}"/>
+                </a:ext>
+              </a:extLst>
+            </p:cNvPr>
+            <p:cNvSpPr/>
+            <p:nvPr/>
+          </p:nvSpPr>
+          <p:spPr>
+            <a:xfrm>
+              <a:off x="3989614" y="6056845"/>
+              <a:ext cx="232268" cy="210312"/>
+            </a:xfrm>
+            <a:prstGeom prst="rightArrow">
+              <a:avLst/>
+            </a:prstGeom>
+            <a:noFill/>
+            <a:ln w="15875">
+              <a:solidFill>
+                <a:srgbClr val="C00000"/>
+              </a:solidFill>
+            </a:ln>
+          </p:spPr>
+          <p:style>
+            <a:lnRef idx="2">
+              <a:schemeClr val="accent1">
+                <a:shade val="15000"/>
+              </a:schemeClr>
+            </a:lnRef>
+            <a:fillRef idx="1">
+              <a:schemeClr val="accent1"/>
+            </a:fillRef>
+            <a:effectRef idx="0">
+              <a:schemeClr val="accent1"/>
+            </a:effectRef>
+            <a:fontRef idx="minor">
+              <a:schemeClr val="lt1"/>
+            </a:fontRef>
+          </p:style>
+          <p:txBody>
+            <a:bodyPr rtlCol="0" anchor="ctr"/>
+            <a:lstStyle/>
+            <a:p>
+              <a:pPr algn="ctr"/>
+              <a:endParaRPr lang="en-US"/>
+            </a:p>
+          </p:txBody>
+        </p:sp>
+        <p:sp>
+          <p:nvSpPr>
+            <p:cNvPr id="18" name="TextBox 17">
+              <a:extLst>
+                <a:ext uri="{FF2B5EF4-FFF2-40B4-BE49-F238E27FC236}">
+                  <a16:creationId xmlns:a16="http://schemas.microsoft.com/office/drawing/2014/main" id="{CF595B35-7401-43AF-7846-68DD2A44B44C}"/>
                 </a:ext>
               </a:extLst>
             </p:cNvPr>
@@ -4288,8 +4649,8 @@
           </p:nvSpPr>
           <p:spPr>
             <a:xfrm>
-              <a:off x="3621575" y="3637616"/>
-              <a:ext cx="2467342" cy="369332"/>
+              <a:off x="4226757" y="5720437"/>
+              <a:ext cx="1209339" cy="276999"/>
             </a:xfrm>
             <a:prstGeom prst="rect">
               <a:avLst/>
@@ -4303,11 +4664,47 @@
             <a:lstStyle/>
             <a:p>
               <a:r>
-                <a:rPr lang="en-US" dirty="0">
+                <a:rPr lang="en-US" sz="1200" dirty="0">
                   <a:latin typeface="Helvetica" pitchFamily="2" charset="0"/>
-                  <a:cs typeface="Arial" panose="020B0604020202020204" pitchFamily="34" charset="0"/>
                 </a:rPr>
-                <a:t>c) Fitted sparse model</a:t>
+                <a:t>Positive weight</a:t>
+              </a:r>
+            </a:p>
+          </p:txBody>
+        </p:sp>
+        <p:sp>
+          <p:nvSpPr>
+            <p:cNvPr id="19" name="TextBox 18">
+              <a:extLst>
+                <a:ext uri="{FF2B5EF4-FFF2-40B4-BE49-F238E27FC236}">
+                  <a16:creationId xmlns:a16="http://schemas.microsoft.com/office/drawing/2014/main" id="{994AF134-1C70-5AF7-BB60-3BEABEE8399F}"/>
+                </a:ext>
+              </a:extLst>
+            </p:cNvPr>
+            <p:cNvSpPr txBox="1"/>
+            <p:nvPr/>
+          </p:nvSpPr>
+          <p:spPr>
+            <a:xfrm>
+              <a:off x="4226757" y="6038907"/>
+              <a:ext cx="1281347" cy="276999"/>
+            </a:xfrm>
+            <a:prstGeom prst="rect">
+              <a:avLst/>
+            </a:prstGeom>
+            <a:noFill/>
+          </p:spPr>
+          <p:txBody>
+            <a:bodyPr wrap="square" rtlCol="0">
+              <a:spAutoFit/>
+            </a:bodyPr>
+            <a:lstStyle/>
+            <a:p>
+              <a:r>
+                <a:rPr lang="en-US" sz="1200" dirty="0">
+                  <a:latin typeface="Helvetica" pitchFamily="2" charset="0"/>
+                </a:rPr>
+                <a:t>Negative weight</a:t>
               </a:r>
             </a:p>
           </p:txBody>

</xml_diff>